<commit_message>
Update 문장 만들기 행동지령 presentation files
Co-Authored-By: Claude Opus 4.6 (1M context) <noreply@anthropic.com>
</commit_message>
<xml_diff>
--- a/public/downloads/games/action-command/rules.pptx
+++ b/public/downloads/games/action-command/rules.pptx
@@ -29,22 +29,21 @@
     <p:sldId id="277" r:id="rId27"/>
     <p:sldId id="278" r:id="rId28"/>
     <p:sldId id="279" r:id="rId29"/>
-    <p:sldId id="280" r:id="rId30"/>
   </p:sldIdLst>
   <p:sldSz cx="18288000" cy="10287000"/>
   <p:notesSz cx="6858000" cy="9144000"/>
   <p:embeddedFontLst>
     <p:embeddedFont>
       <p:font typeface="Jua" charset="1" panose="00000000000000000000"/>
+      <p:regular r:id="rId30"/>
+    </p:embeddedFont>
+    <p:embeddedFont>
+      <p:font typeface="TDTD갬성명조" charset="1" panose="02000503000000000000"/>
       <p:regular r:id="rId31"/>
     </p:embeddedFont>
     <p:embeddedFont>
-      <p:font typeface="TDTD갬성명조" charset="1" panose="02000503000000000000"/>
+      <p:font typeface="TDTD가온" charset="1" panose="02000503000000000000"/>
       <p:regular r:id="rId32"/>
-    </p:embeddedFont>
-    <p:embeddedFont>
-      <p:font typeface="TDTD가온" charset="1" panose="02000503000000000000"/>
-      <p:regular r:id="rId33"/>
     </p:embeddedFont>
   </p:embeddedFontLst>
   <p:defaultTextStyle>
@@ -3248,129 +3247,6 @@
 </file>
 
 <file path=ppt/slides/slide10.xml><?xml version="1.0" encoding="utf-8"?>
-<p:sld xmlns:p="http://schemas.openxmlformats.org/presentationml/2006/main" xmlns:a="http://schemas.openxmlformats.org/drawingml/2006/main" xmlns:r="http://schemas.openxmlformats.org/officeDocument/2006/relationships">
-  <p:cSld>
-    <p:bg>
-      <p:bgPr>
-        <a:solidFill>
-          <a:srgbClr val="FFFAEF"/>
-        </a:solidFill>
-      </p:bgPr>
-    </p:bg>
-    <p:spTree>
-      <p:nvGrpSpPr>
-        <p:cNvPr id="1" name=""/>
-        <p:cNvGrpSpPr/>
-        <p:nvPr/>
-      </p:nvGrpSpPr>
-      <p:grpSpPr>
-        <a:xfrm>
-          <a:off x="0" y="0"/>
-          <a:ext cx="0" cy="0"/>
-          <a:chOff x="0" y="0"/>
-          <a:chExt cx="0" cy="0"/>
-        </a:xfrm>
-      </p:grpSpPr>
-      <p:pic>
-        <p:nvPicPr>
-          <p:cNvPr name="Picture 2" id="2"/>
-          <p:cNvPicPr>
-            <a:picLocks noChangeAspect="true"/>
-          </p:cNvPicPr>
-          <p:nvPr/>
-        </p:nvPicPr>
-        <p:blipFill>
-          <a:blip r:embed="rId2"/>
-          <a:srcRect l="0" t="0" r="0" b="0"/>
-          <a:stretch>
-            <a:fillRect/>
-          </a:stretch>
-        </p:blipFill>
-        <p:spPr>
-          <a:xfrm flipH="false" flipV="false" rot="0">
-            <a:off x="13655377" y="6809666"/>
-            <a:ext cx="6229999" cy="6954669"/>
-          </a:xfrm>
-          <a:prstGeom prst="rect">
-            <a:avLst/>
-          </a:prstGeom>
-        </p:spPr>
-      </p:pic>
-      <p:pic>
-        <p:nvPicPr>
-          <p:cNvPr name="Picture 3" id="3"/>
-          <p:cNvPicPr>
-            <a:picLocks noChangeAspect="true"/>
-          </p:cNvPicPr>
-          <p:nvPr/>
-        </p:nvPicPr>
-        <p:blipFill>
-          <a:blip r:embed="rId3"/>
-          <a:srcRect l="0" t="0" r="0" b="0"/>
-          <a:stretch>
-            <a:fillRect/>
-          </a:stretch>
-        </p:blipFill>
-        <p:spPr>
-          <a:xfrm flipH="false" flipV="false" rot="0">
-            <a:off x="0" y="0"/>
-            <a:ext cx="6925457" cy="4700654"/>
-          </a:xfrm>
-          <a:prstGeom prst="rect">
-            <a:avLst/>
-          </a:prstGeom>
-        </p:spPr>
-      </p:pic>
-      <p:sp>
-        <p:nvSpPr>
-          <p:cNvPr name="TextBox 4" id="4"/>
-          <p:cNvSpPr txBox="true"/>
-          <p:nvPr/>
-        </p:nvSpPr>
-        <p:spPr>
-          <a:xfrm rot="0">
-            <a:off x="2717556" y="3895725"/>
-            <a:ext cx="12852888" cy="2200275"/>
-          </a:xfrm>
-          <a:prstGeom prst="rect">
-            <a:avLst/>
-          </a:prstGeom>
-        </p:spPr>
-        <p:txBody>
-          <a:bodyPr anchor="t" rtlCol="false" tIns="0" lIns="0" bIns="0" rIns="0">
-            <a:spAutoFit/>
-          </a:bodyPr>
-          <a:lstStyle/>
-          <a:p>
-            <a:pPr algn="ctr">
-              <a:lnSpc>
-                <a:spcPts val="15000"/>
-              </a:lnSpc>
-            </a:pPr>
-            <a:r>
-              <a:rPr lang="en-US" sz="12500">
-                <a:solidFill>
-                  <a:srgbClr val="000000"/>
-                </a:solidFill>
-                <a:latin typeface="Jua"/>
-                <a:ea typeface="Jua"/>
-                <a:cs typeface="Jua"/>
-                <a:sym typeface="Jua"/>
-              </a:rPr>
-              <a:t>양손 들고 제자리 돌기</a:t>
-            </a:r>
-          </a:p>
-        </p:txBody>
-      </p:sp>
-    </p:spTree>
-  </p:cSld>
-  <p:clrMapOvr>
-    <a:masterClrMapping/>
-  </p:clrMapOvr>
-</p:sld>
-</file>
-
-<file path=ppt/slides/slide11.xml><?xml version="1.0" encoding="utf-8"?>
 <p:sld xmlns:p="http://schemas.openxmlformats.org/presentationml/2006/main" xmlns:a="http://schemas.openxmlformats.org/drawingml/2006/main">
   <p:cSld>
     <p:bg>
@@ -4018,7 +3894,7 @@
 </p:sld>
 </file>
 
-<file path=ppt/slides/slide12.xml><?xml version="1.0" encoding="utf-8"?>
+<file path=ppt/slides/slide11.xml><?xml version="1.0" encoding="utf-8"?>
 <p:sld xmlns:p="http://schemas.openxmlformats.org/presentationml/2006/main" xmlns:a="http://schemas.openxmlformats.org/drawingml/2006/main" xmlns:r="http://schemas.openxmlformats.org/officeDocument/2006/relationships">
   <p:cSld>
     <p:bg>
@@ -4141,7 +4017,7 @@
 </p:sld>
 </file>
 
-<file path=ppt/slides/slide13.xml><?xml version="1.0" encoding="utf-8"?>
+<file path=ppt/slides/slide12.xml><?xml version="1.0" encoding="utf-8"?>
 <p:sld xmlns:p="http://schemas.openxmlformats.org/presentationml/2006/main" xmlns:a="http://schemas.openxmlformats.org/drawingml/2006/main">
   <p:cSld>
     <p:bg>
@@ -4985,7 +4861,7 @@
 </p:sld>
 </file>
 
-<file path=ppt/slides/slide14.xml><?xml version="1.0" encoding="utf-8"?>
+<file path=ppt/slides/slide13.xml><?xml version="1.0" encoding="utf-8"?>
 <p:sld xmlns:p="http://schemas.openxmlformats.org/presentationml/2006/main" xmlns:a="http://schemas.openxmlformats.org/drawingml/2006/main" xmlns:r="http://schemas.openxmlformats.org/officeDocument/2006/relationships">
   <p:cSld>
     <p:bg>
@@ -5108,7 +4984,7 @@
 </p:sld>
 </file>
 
-<file path=ppt/slides/slide15.xml><?xml version="1.0" encoding="utf-8"?>
+<file path=ppt/slides/slide14.xml><?xml version="1.0" encoding="utf-8"?>
 <p:sld xmlns:p="http://schemas.openxmlformats.org/presentationml/2006/main" xmlns:a="http://schemas.openxmlformats.org/drawingml/2006/main">
   <p:cSld>
     <p:bg>
@@ -5952,7 +5828,7 @@
 </p:sld>
 </file>
 
-<file path=ppt/slides/slide16.xml><?xml version="1.0" encoding="utf-8"?>
+<file path=ppt/slides/slide15.xml><?xml version="1.0" encoding="utf-8"?>
 <p:sld xmlns:p="http://schemas.openxmlformats.org/presentationml/2006/main" xmlns:a="http://schemas.openxmlformats.org/drawingml/2006/main" xmlns:r="http://schemas.openxmlformats.org/officeDocument/2006/relationships">
   <p:cSld>
     <p:bg>
@@ -6075,7 +5951,7 @@
 </p:sld>
 </file>
 
-<file path=ppt/slides/slide17.xml><?xml version="1.0" encoding="utf-8"?>
+<file path=ppt/slides/slide16.xml><?xml version="1.0" encoding="utf-8"?>
 <p:sld xmlns:p="http://schemas.openxmlformats.org/presentationml/2006/main" xmlns:a="http://schemas.openxmlformats.org/drawingml/2006/main">
   <p:cSld>
     <p:bg>
@@ -6919,7 +6795,7 @@
 </p:sld>
 </file>
 
-<file path=ppt/slides/slide18.xml><?xml version="1.0" encoding="utf-8"?>
+<file path=ppt/slides/slide17.xml><?xml version="1.0" encoding="utf-8"?>
 <p:sld xmlns:p="http://schemas.openxmlformats.org/presentationml/2006/main" xmlns:a="http://schemas.openxmlformats.org/drawingml/2006/main" xmlns:r="http://schemas.openxmlformats.org/officeDocument/2006/relationships">
   <p:cSld>
     <p:bg>
@@ -7042,7 +6918,7 @@
 </p:sld>
 </file>
 
-<file path=ppt/slides/slide19.xml><?xml version="1.0" encoding="utf-8"?>
+<file path=ppt/slides/slide18.xml><?xml version="1.0" encoding="utf-8"?>
 <p:sld xmlns:p="http://schemas.openxmlformats.org/presentationml/2006/main" xmlns:a="http://schemas.openxmlformats.org/drawingml/2006/main">
   <p:cSld>
     <p:bg>
@@ -7878,6 +7754,129 @@
           </a:graphicData>
         </a:graphic>
       </p:graphicFrame>
+    </p:spTree>
+  </p:cSld>
+  <p:clrMapOvr>
+    <a:masterClrMapping/>
+  </p:clrMapOvr>
+</p:sld>
+</file>
+
+<file path=ppt/slides/slide19.xml><?xml version="1.0" encoding="utf-8"?>
+<p:sld xmlns:p="http://schemas.openxmlformats.org/presentationml/2006/main" xmlns:a="http://schemas.openxmlformats.org/drawingml/2006/main" xmlns:r="http://schemas.openxmlformats.org/officeDocument/2006/relationships">
+  <p:cSld>
+    <p:bg>
+      <p:bgPr>
+        <a:solidFill>
+          <a:srgbClr val="FFFAEF"/>
+        </a:solidFill>
+      </p:bgPr>
+    </p:bg>
+    <p:spTree>
+      <p:nvGrpSpPr>
+        <p:cNvPr id="1" name=""/>
+        <p:cNvGrpSpPr/>
+        <p:nvPr/>
+      </p:nvGrpSpPr>
+      <p:grpSpPr>
+        <a:xfrm>
+          <a:off x="0" y="0"/>
+          <a:ext cx="0" cy="0"/>
+          <a:chOff x="0" y="0"/>
+          <a:chExt cx="0" cy="0"/>
+        </a:xfrm>
+      </p:grpSpPr>
+      <p:pic>
+        <p:nvPicPr>
+          <p:cNvPr name="Picture 2" id="2"/>
+          <p:cNvPicPr>
+            <a:picLocks noChangeAspect="true"/>
+          </p:cNvPicPr>
+          <p:nvPr/>
+        </p:nvPicPr>
+        <p:blipFill>
+          <a:blip r:embed="rId2"/>
+          <a:srcRect l="0" t="0" r="0" b="0"/>
+          <a:stretch>
+            <a:fillRect/>
+          </a:stretch>
+        </p:blipFill>
+        <p:spPr>
+          <a:xfrm flipH="false" flipV="false" rot="0">
+            <a:off x="13655377" y="6809666"/>
+            <a:ext cx="6229999" cy="6954669"/>
+          </a:xfrm>
+          <a:prstGeom prst="rect">
+            <a:avLst/>
+          </a:prstGeom>
+        </p:spPr>
+      </p:pic>
+      <p:pic>
+        <p:nvPicPr>
+          <p:cNvPr name="Picture 3" id="3"/>
+          <p:cNvPicPr>
+            <a:picLocks noChangeAspect="true"/>
+          </p:cNvPicPr>
+          <p:nvPr/>
+        </p:nvPicPr>
+        <p:blipFill>
+          <a:blip r:embed="rId3"/>
+          <a:srcRect l="0" t="0" r="0" b="0"/>
+          <a:stretch>
+            <a:fillRect/>
+          </a:stretch>
+        </p:blipFill>
+        <p:spPr>
+          <a:xfrm flipH="false" flipV="false" rot="0">
+            <a:off x="0" y="0"/>
+            <a:ext cx="6925457" cy="4700654"/>
+          </a:xfrm>
+          <a:prstGeom prst="rect">
+            <a:avLst/>
+          </a:prstGeom>
+        </p:spPr>
+      </p:pic>
+      <p:sp>
+        <p:nvSpPr>
+          <p:cNvPr name="TextBox 4" id="4"/>
+          <p:cNvSpPr txBox="true"/>
+          <p:nvPr/>
+        </p:nvSpPr>
+        <p:spPr>
+          <a:xfrm rot="0">
+            <a:off x="461635" y="3895725"/>
+            <a:ext cx="17364730" cy="2200275"/>
+          </a:xfrm>
+          <a:prstGeom prst="rect">
+            <a:avLst/>
+          </a:prstGeom>
+        </p:spPr>
+        <p:txBody>
+          <a:bodyPr anchor="t" rtlCol="false" tIns="0" lIns="0" bIns="0" rIns="0">
+            <a:spAutoFit/>
+          </a:bodyPr>
+          <a:lstStyle/>
+          <a:p>
+            <a:pPr algn="ctr">
+              <a:lnSpc>
+                <a:spcPts val="15000"/>
+              </a:lnSpc>
+            </a:pPr>
+            <a:r>
+              <a:rPr lang="en-US" sz="12500">
+                <a:solidFill>
+                  <a:srgbClr val="000000"/>
+                </a:solidFill>
+                <a:latin typeface="Jua"/>
+                <a:ea typeface="Jua"/>
+                <a:cs typeface="Jua"/>
+                <a:sym typeface="Jua"/>
+              </a:rPr>
+              <a:t>눈 감고 한발로 십초간 버티기</a:t>
+            </a:r>
+          </a:p>
+        </p:txBody>
+      </p:sp>
     </p:spTree>
   </p:cSld>
   <p:clrMapOvr>
@@ -8410,129 +8409,6 @@
 </file>
 
 <file path=ppt/slides/slide20.xml><?xml version="1.0" encoding="utf-8"?>
-<p:sld xmlns:p="http://schemas.openxmlformats.org/presentationml/2006/main" xmlns:a="http://schemas.openxmlformats.org/drawingml/2006/main" xmlns:r="http://schemas.openxmlformats.org/officeDocument/2006/relationships">
-  <p:cSld>
-    <p:bg>
-      <p:bgPr>
-        <a:solidFill>
-          <a:srgbClr val="FFFAEF"/>
-        </a:solidFill>
-      </p:bgPr>
-    </p:bg>
-    <p:spTree>
-      <p:nvGrpSpPr>
-        <p:cNvPr id="1" name=""/>
-        <p:cNvGrpSpPr/>
-        <p:nvPr/>
-      </p:nvGrpSpPr>
-      <p:grpSpPr>
-        <a:xfrm>
-          <a:off x="0" y="0"/>
-          <a:ext cx="0" cy="0"/>
-          <a:chOff x="0" y="0"/>
-          <a:chExt cx="0" cy="0"/>
-        </a:xfrm>
-      </p:grpSpPr>
-      <p:pic>
-        <p:nvPicPr>
-          <p:cNvPr name="Picture 2" id="2"/>
-          <p:cNvPicPr>
-            <a:picLocks noChangeAspect="true"/>
-          </p:cNvPicPr>
-          <p:nvPr/>
-        </p:nvPicPr>
-        <p:blipFill>
-          <a:blip r:embed="rId2"/>
-          <a:srcRect l="0" t="0" r="0" b="0"/>
-          <a:stretch>
-            <a:fillRect/>
-          </a:stretch>
-        </p:blipFill>
-        <p:spPr>
-          <a:xfrm flipH="false" flipV="false" rot="0">
-            <a:off x="13655377" y="6809666"/>
-            <a:ext cx="6229999" cy="6954669"/>
-          </a:xfrm>
-          <a:prstGeom prst="rect">
-            <a:avLst/>
-          </a:prstGeom>
-        </p:spPr>
-      </p:pic>
-      <p:pic>
-        <p:nvPicPr>
-          <p:cNvPr name="Picture 3" id="3"/>
-          <p:cNvPicPr>
-            <a:picLocks noChangeAspect="true"/>
-          </p:cNvPicPr>
-          <p:nvPr/>
-        </p:nvPicPr>
-        <p:blipFill>
-          <a:blip r:embed="rId3"/>
-          <a:srcRect l="0" t="0" r="0" b="0"/>
-          <a:stretch>
-            <a:fillRect/>
-          </a:stretch>
-        </p:blipFill>
-        <p:spPr>
-          <a:xfrm flipH="false" flipV="false" rot="0">
-            <a:off x="0" y="0"/>
-            <a:ext cx="6925457" cy="4700654"/>
-          </a:xfrm>
-          <a:prstGeom prst="rect">
-            <a:avLst/>
-          </a:prstGeom>
-        </p:spPr>
-      </p:pic>
-      <p:sp>
-        <p:nvSpPr>
-          <p:cNvPr name="TextBox 4" id="4"/>
-          <p:cNvSpPr txBox="true"/>
-          <p:nvPr/>
-        </p:nvSpPr>
-        <p:spPr>
-          <a:xfrm rot="0">
-            <a:off x="461635" y="3895725"/>
-            <a:ext cx="17364730" cy="2200275"/>
-          </a:xfrm>
-          <a:prstGeom prst="rect">
-            <a:avLst/>
-          </a:prstGeom>
-        </p:spPr>
-        <p:txBody>
-          <a:bodyPr anchor="t" rtlCol="false" tIns="0" lIns="0" bIns="0" rIns="0">
-            <a:spAutoFit/>
-          </a:bodyPr>
-          <a:lstStyle/>
-          <a:p>
-            <a:pPr algn="ctr">
-              <a:lnSpc>
-                <a:spcPts val="15000"/>
-              </a:lnSpc>
-            </a:pPr>
-            <a:r>
-              <a:rPr lang="en-US" sz="12500">
-                <a:solidFill>
-                  <a:srgbClr val="000000"/>
-                </a:solidFill>
-                <a:latin typeface="Jua"/>
-                <a:ea typeface="Jua"/>
-                <a:cs typeface="Jua"/>
-                <a:sym typeface="Jua"/>
-              </a:rPr>
-              <a:t>눈 감고 한발로 십초간 버티기</a:t>
-            </a:r>
-          </a:p>
-        </p:txBody>
-      </p:sp>
-    </p:spTree>
-  </p:cSld>
-  <p:clrMapOvr>
-    <a:masterClrMapping/>
-  </p:clrMapOvr>
-</p:sld>
-</file>
-
-<file path=ppt/slides/slide21.xml><?xml version="1.0" encoding="utf-8"?>
 <p:sld xmlns:p="http://schemas.openxmlformats.org/presentationml/2006/main" xmlns:a="http://schemas.openxmlformats.org/drawingml/2006/main">
   <p:cSld>
     <p:bg>
@@ -9376,7 +9252,7 @@
 </p:sld>
 </file>
 
-<file path=ppt/slides/slide22.xml><?xml version="1.0" encoding="utf-8"?>
+<file path=ppt/slides/slide21.xml><?xml version="1.0" encoding="utf-8"?>
 <p:sld xmlns:p="http://schemas.openxmlformats.org/presentationml/2006/main" xmlns:a="http://schemas.openxmlformats.org/drawingml/2006/main" xmlns:r="http://schemas.openxmlformats.org/officeDocument/2006/relationships">
   <p:cSld>
     <p:bg>
@@ -9499,7 +9375,7 @@
 </p:sld>
 </file>
 
-<file path=ppt/slides/slide23.xml><?xml version="1.0" encoding="utf-8"?>
+<file path=ppt/slides/slide22.xml><?xml version="1.0" encoding="utf-8"?>
 <p:sld xmlns:p="http://schemas.openxmlformats.org/presentationml/2006/main" xmlns:a="http://schemas.openxmlformats.org/drawingml/2006/main">
   <p:cSld>
     <p:bg>
@@ -10343,7 +10219,7 @@
 </p:sld>
 </file>
 
-<file path=ppt/slides/slide24.xml><?xml version="1.0" encoding="utf-8"?>
+<file path=ppt/slides/slide23.xml><?xml version="1.0" encoding="utf-8"?>
 <p:sld xmlns:p="http://schemas.openxmlformats.org/presentationml/2006/main" xmlns:a="http://schemas.openxmlformats.org/drawingml/2006/main" xmlns:r="http://schemas.openxmlformats.org/officeDocument/2006/relationships">
   <p:cSld>
     <p:bg>
@@ -10466,7 +10342,7 @@
 </p:sld>
 </file>
 
-<file path=ppt/slides/slide25.xml><?xml version="1.0" encoding="utf-8"?>
+<file path=ppt/slides/slide24.xml><?xml version="1.0" encoding="utf-8"?>
 <p:sld xmlns:p="http://schemas.openxmlformats.org/presentationml/2006/main" xmlns:a="http://schemas.openxmlformats.org/drawingml/2006/main" xmlns:r="http://schemas.openxmlformats.org/officeDocument/2006/relationships">
   <p:cSld>
     <p:bg>
@@ -10615,129 +10491,6 @@
 </file>
 
 <file path=ppt/slides/slide3.xml><?xml version="1.0" encoding="utf-8"?>
-<p:sld xmlns:p="http://schemas.openxmlformats.org/presentationml/2006/main" xmlns:a="http://schemas.openxmlformats.org/drawingml/2006/main" xmlns:r="http://schemas.openxmlformats.org/officeDocument/2006/relationships">
-  <p:cSld>
-    <p:bg>
-      <p:bgPr>
-        <a:solidFill>
-          <a:srgbClr val="FFFAEF"/>
-        </a:solidFill>
-      </p:bgPr>
-    </p:bg>
-    <p:spTree>
-      <p:nvGrpSpPr>
-        <p:cNvPr id="1" name=""/>
-        <p:cNvGrpSpPr/>
-        <p:nvPr/>
-      </p:nvGrpSpPr>
-      <p:grpSpPr>
-        <a:xfrm>
-          <a:off x="0" y="0"/>
-          <a:ext cx="0" cy="0"/>
-          <a:chOff x="0" y="0"/>
-          <a:chExt cx="0" cy="0"/>
-        </a:xfrm>
-      </p:grpSpPr>
-      <p:sp>
-        <p:nvSpPr>
-          <p:cNvPr name="TextBox 2" id="2"/>
-          <p:cNvSpPr txBox="true"/>
-          <p:nvPr/>
-        </p:nvSpPr>
-        <p:spPr>
-          <a:xfrm rot="0">
-            <a:off x="3238925" y="4092795"/>
-            <a:ext cx="11810151" cy="2200275"/>
-          </a:xfrm>
-          <a:prstGeom prst="rect">
-            <a:avLst/>
-          </a:prstGeom>
-        </p:spPr>
-        <p:txBody>
-          <a:bodyPr anchor="t" rtlCol="false" tIns="0" lIns="0" bIns="0" rIns="0">
-            <a:spAutoFit/>
-          </a:bodyPr>
-          <a:lstStyle/>
-          <a:p>
-            <a:pPr algn="ctr">
-              <a:lnSpc>
-                <a:spcPts val="15000"/>
-              </a:lnSpc>
-            </a:pPr>
-            <a:r>
-              <a:rPr lang="en-US" sz="12500">
-                <a:solidFill>
-                  <a:srgbClr val="000000"/>
-                </a:solidFill>
-                <a:latin typeface="Jua"/>
-                <a:ea typeface="Jua"/>
-                <a:cs typeface="Jua"/>
-                <a:sym typeface="Jua"/>
-              </a:rPr>
-              <a:t>팀을 나눠주세요!</a:t>
-            </a:r>
-          </a:p>
-        </p:txBody>
-      </p:sp>
-      <p:pic>
-        <p:nvPicPr>
-          <p:cNvPr name="Picture 3" id="3"/>
-          <p:cNvPicPr>
-            <a:picLocks noChangeAspect="true"/>
-          </p:cNvPicPr>
-          <p:nvPr/>
-        </p:nvPicPr>
-        <p:blipFill>
-          <a:blip r:embed="rId2"/>
-          <a:srcRect l="0" t="0" r="0" b="0"/>
-          <a:stretch>
-            <a:fillRect/>
-          </a:stretch>
-        </p:blipFill>
-        <p:spPr>
-          <a:xfrm flipH="false" flipV="false" rot="0">
-            <a:off x="13655377" y="6809666"/>
-            <a:ext cx="6229999" cy="6954669"/>
-          </a:xfrm>
-          <a:prstGeom prst="rect">
-            <a:avLst/>
-          </a:prstGeom>
-        </p:spPr>
-      </p:pic>
-      <p:pic>
-        <p:nvPicPr>
-          <p:cNvPr name="Picture 4" id="4"/>
-          <p:cNvPicPr>
-            <a:picLocks noChangeAspect="true"/>
-          </p:cNvPicPr>
-          <p:nvPr/>
-        </p:nvPicPr>
-        <p:blipFill>
-          <a:blip r:embed="rId3"/>
-          <a:srcRect l="0" t="0" r="0" b="0"/>
-          <a:stretch>
-            <a:fillRect/>
-          </a:stretch>
-        </p:blipFill>
-        <p:spPr>
-          <a:xfrm flipH="false" flipV="false" rot="0">
-            <a:off x="0" y="0"/>
-            <a:ext cx="6925457" cy="4700654"/>
-          </a:xfrm>
-          <a:prstGeom prst="rect">
-            <a:avLst/>
-          </a:prstGeom>
-        </p:spPr>
-      </p:pic>
-    </p:spTree>
-  </p:cSld>
-  <p:clrMapOvr>
-    <a:masterClrMapping/>
-  </p:clrMapOvr>
-</p:sld>
-</file>
-
-<file path=ppt/slides/slide4.xml><?xml version="1.0" encoding="utf-8"?>
 <p:sld xmlns:p="http://schemas.openxmlformats.org/presentationml/2006/main" xmlns:a="http://schemas.openxmlformats.org/drawingml/2006/main" xmlns:r="http://schemas.openxmlformats.org/officeDocument/2006/relationships">
   <p:cSld>
     <p:bg>
@@ -10904,7 +10657,7 @@
 </p:sld>
 </file>
 
-<file path=ppt/slides/slide5.xml><?xml version="1.0" encoding="utf-8"?>
+<file path=ppt/slides/slide4.xml><?xml version="1.0" encoding="utf-8"?>
 <p:sld xmlns:p="http://schemas.openxmlformats.org/presentationml/2006/main" xmlns:a="http://schemas.openxmlformats.org/drawingml/2006/main">
   <p:cSld>
     <p:bg>
@@ -11552,7 +11305,7 @@
 </p:sld>
 </file>
 
-<file path=ppt/slides/slide6.xml><?xml version="1.0" encoding="utf-8"?>
+<file path=ppt/slides/slide5.xml><?xml version="1.0" encoding="utf-8"?>
 <p:sld xmlns:p="http://schemas.openxmlformats.org/presentationml/2006/main" xmlns:a="http://schemas.openxmlformats.org/drawingml/2006/main" xmlns:r="http://schemas.openxmlformats.org/officeDocument/2006/relationships">
   <p:cSld>
     <p:bg>
@@ -11675,7 +11428,7 @@
 </p:sld>
 </file>
 
-<file path=ppt/slides/slide7.xml><?xml version="1.0" encoding="utf-8"?>
+<file path=ppt/slides/slide6.xml><?xml version="1.0" encoding="utf-8"?>
 <p:sld xmlns:p="http://schemas.openxmlformats.org/presentationml/2006/main" xmlns:a="http://schemas.openxmlformats.org/drawingml/2006/main">
   <p:cSld>
     <p:bg>
@@ -12323,7 +12076,7 @@
 </p:sld>
 </file>
 
-<file path=ppt/slides/slide8.xml><?xml version="1.0" encoding="utf-8"?>
+<file path=ppt/slides/slide7.xml><?xml version="1.0" encoding="utf-8"?>
 <p:sld xmlns:p="http://schemas.openxmlformats.org/presentationml/2006/main" xmlns:a="http://schemas.openxmlformats.org/drawingml/2006/main" xmlns:r="http://schemas.openxmlformats.org/officeDocument/2006/relationships">
   <p:cSld>
     <p:bg>
@@ -12446,7 +12199,7 @@
 </p:sld>
 </file>
 
-<file path=ppt/slides/slide9.xml><?xml version="1.0" encoding="utf-8"?>
+<file path=ppt/slides/slide8.xml><?xml version="1.0" encoding="utf-8"?>
 <p:sld xmlns:p="http://schemas.openxmlformats.org/presentationml/2006/main" xmlns:a="http://schemas.openxmlformats.org/drawingml/2006/main">
   <p:cSld>
     <p:bg>
@@ -13086,6 +12839,129 @@
           </a:graphicData>
         </a:graphic>
       </p:graphicFrame>
+    </p:spTree>
+  </p:cSld>
+  <p:clrMapOvr>
+    <a:masterClrMapping/>
+  </p:clrMapOvr>
+</p:sld>
+</file>
+
+<file path=ppt/slides/slide9.xml><?xml version="1.0" encoding="utf-8"?>
+<p:sld xmlns:p="http://schemas.openxmlformats.org/presentationml/2006/main" xmlns:a="http://schemas.openxmlformats.org/drawingml/2006/main" xmlns:r="http://schemas.openxmlformats.org/officeDocument/2006/relationships">
+  <p:cSld>
+    <p:bg>
+      <p:bgPr>
+        <a:solidFill>
+          <a:srgbClr val="FFFAEF"/>
+        </a:solidFill>
+      </p:bgPr>
+    </p:bg>
+    <p:spTree>
+      <p:nvGrpSpPr>
+        <p:cNvPr id="1" name=""/>
+        <p:cNvGrpSpPr/>
+        <p:nvPr/>
+      </p:nvGrpSpPr>
+      <p:grpSpPr>
+        <a:xfrm>
+          <a:off x="0" y="0"/>
+          <a:ext cx="0" cy="0"/>
+          <a:chOff x="0" y="0"/>
+          <a:chExt cx="0" cy="0"/>
+        </a:xfrm>
+      </p:grpSpPr>
+      <p:pic>
+        <p:nvPicPr>
+          <p:cNvPr name="Picture 2" id="2"/>
+          <p:cNvPicPr>
+            <a:picLocks noChangeAspect="true"/>
+          </p:cNvPicPr>
+          <p:nvPr/>
+        </p:nvPicPr>
+        <p:blipFill>
+          <a:blip r:embed="rId2"/>
+          <a:srcRect l="0" t="0" r="0" b="0"/>
+          <a:stretch>
+            <a:fillRect/>
+          </a:stretch>
+        </p:blipFill>
+        <p:spPr>
+          <a:xfrm flipH="false" flipV="false" rot="0">
+            <a:off x="13655377" y="6809666"/>
+            <a:ext cx="6229999" cy="6954669"/>
+          </a:xfrm>
+          <a:prstGeom prst="rect">
+            <a:avLst/>
+          </a:prstGeom>
+        </p:spPr>
+      </p:pic>
+      <p:pic>
+        <p:nvPicPr>
+          <p:cNvPr name="Picture 3" id="3"/>
+          <p:cNvPicPr>
+            <a:picLocks noChangeAspect="true"/>
+          </p:cNvPicPr>
+          <p:nvPr/>
+        </p:nvPicPr>
+        <p:blipFill>
+          <a:blip r:embed="rId3"/>
+          <a:srcRect l="0" t="0" r="0" b="0"/>
+          <a:stretch>
+            <a:fillRect/>
+          </a:stretch>
+        </p:blipFill>
+        <p:spPr>
+          <a:xfrm flipH="false" flipV="false" rot="0">
+            <a:off x="0" y="0"/>
+            <a:ext cx="6925457" cy="4700654"/>
+          </a:xfrm>
+          <a:prstGeom prst="rect">
+            <a:avLst/>
+          </a:prstGeom>
+        </p:spPr>
+      </p:pic>
+      <p:sp>
+        <p:nvSpPr>
+          <p:cNvPr name="TextBox 4" id="4"/>
+          <p:cNvSpPr txBox="true"/>
+          <p:nvPr/>
+        </p:nvSpPr>
+        <p:spPr>
+          <a:xfrm rot="0">
+            <a:off x="2717556" y="3895725"/>
+            <a:ext cx="12852888" cy="2200275"/>
+          </a:xfrm>
+          <a:prstGeom prst="rect">
+            <a:avLst/>
+          </a:prstGeom>
+        </p:spPr>
+        <p:txBody>
+          <a:bodyPr anchor="t" rtlCol="false" tIns="0" lIns="0" bIns="0" rIns="0">
+            <a:spAutoFit/>
+          </a:bodyPr>
+          <a:lstStyle/>
+          <a:p>
+            <a:pPr algn="ctr">
+              <a:lnSpc>
+                <a:spcPts val="15000"/>
+              </a:lnSpc>
+            </a:pPr>
+            <a:r>
+              <a:rPr lang="en-US" sz="12500">
+                <a:solidFill>
+                  <a:srgbClr val="000000"/>
+                </a:solidFill>
+                <a:latin typeface="Jua"/>
+                <a:ea typeface="Jua"/>
+                <a:cs typeface="Jua"/>
+                <a:sym typeface="Jua"/>
+              </a:rPr>
+              <a:t>양손 들고 제자리 돌기</a:t>
+            </a:r>
+          </a:p>
+        </p:txBody>
+      </p:sp>
     </p:spTree>
   </p:cSld>
   <p:clrMapOvr>

</xml_diff>

<commit_message>
Update 문장 만들기 행동지령 assets and add ZIP slides
Co-Authored-By: Claude Opus 4.6 (1M context) <noreply@anthropic.com>
</commit_message>
<xml_diff>
--- a/public/downloads/games/action-command/rules.pptx
+++ b/public/downloads/games/action-command/rules.pptx
@@ -55,16 +55,12 @@
   <p:notesSz cx="6858000" cy="9144000"/>
   <p:embeddedFontLst>
     <p:embeddedFont>
-      <p:font typeface="Jua" charset="1" panose="00000000000000000000"/>
+      <p:font typeface="무궁화 고딕" charset="1" panose="02020603020101020101"/>
       <p:regular r:id="rId51"/>
     </p:embeddedFont>
     <p:embeddedFont>
-      <p:font typeface="TDTD갬성명조" charset="1" panose="02000503000000000000"/>
+      <p:font typeface="무궁화 고딕 Bold" charset="1" panose="02020603020101020101"/>
       <p:regular r:id="rId52"/>
-    </p:embeddedFont>
-    <p:embeddedFont>
-      <p:font typeface="TDTD가온" charset="1" panose="02000503000000000000"/>
-      <p:regular r:id="rId53"/>
     </p:embeddedFont>
   </p:embeddedFontLst>
   <p:defaultTextStyle>
@@ -3182,8 +3178,8 @@
         </p:nvSpPr>
         <p:spPr>
           <a:xfrm rot="0">
-            <a:off x="1028700" y="3892867"/>
-            <a:ext cx="15555091" cy="2200275"/>
+            <a:off x="1028700" y="4178617"/>
+            <a:ext cx="15555091" cy="1914525"/>
           </a:xfrm>
           <a:prstGeom prst="rect">
             <a:avLst/>
@@ -3205,10 +3201,10 @@
                 <a:solidFill>
                   <a:srgbClr val="FFFAEF"/>
                 </a:solidFill>
-                <a:latin typeface="Jua"/>
-                <a:ea typeface="Jua"/>
-                <a:cs typeface="Jua"/>
-                <a:sym typeface="Jua"/>
+                <a:latin typeface="무궁화 고딕"/>
+                <a:ea typeface="무궁화 고딕"/>
+                <a:cs typeface="무궁화 고딕"/>
+                <a:sym typeface="무궁화 고딕"/>
               </a:rPr>
               <a:t>문장 만들기 행동지령</a:t>
             </a:r>
@@ -3223,8 +3219,8 @@
         </p:nvSpPr>
         <p:spPr>
           <a:xfrm rot="0">
-            <a:off x="15264803" y="9812655"/>
-            <a:ext cx="2637975" cy="474345"/>
+            <a:off x="14242119" y="9822180"/>
+            <a:ext cx="3660660" cy="464820"/>
           </a:xfrm>
           <a:prstGeom prst="rect">
             <a:avLst/>
@@ -3249,10 +3245,10 @@
                 <a:solidFill>
                   <a:srgbClr val="FFFFFF"/>
                 </a:solidFill>
-                <a:latin typeface="TDTD갬성명조"/>
-                <a:ea typeface="TDTD갬성명조"/>
-                <a:cs typeface="TDTD갬성명조"/>
-                <a:sym typeface="TDTD갬성명조"/>
+                <a:latin typeface="무궁화 고딕"/>
+                <a:ea typeface="무궁화 고딕"/>
+                <a:cs typeface="무궁화 고딕"/>
+                <a:sym typeface="무궁화 고딕"/>
               </a:rPr>
               <a:t>ⓒ 2026. Sunday Play</a:t>
             </a:r>
@@ -3349,8 +3345,8 @@
         </p:nvSpPr>
         <p:spPr>
           <a:xfrm rot="0">
-            <a:off x="2717556" y="3895725"/>
-            <a:ext cx="12852888" cy="2200275"/>
+            <a:off x="2717556" y="4181475"/>
+            <a:ext cx="12852888" cy="1914525"/>
           </a:xfrm>
           <a:prstGeom prst="rect">
             <a:avLst/>
@@ -3372,10 +3368,10 @@
                 <a:solidFill>
                   <a:srgbClr val="000000"/>
                 </a:solidFill>
-                <a:latin typeface="Jua"/>
-                <a:ea typeface="Jua"/>
-                <a:cs typeface="Jua"/>
-                <a:sym typeface="Jua"/>
+                <a:latin typeface="무궁화 고딕"/>
+                <a:ea typeface="무궁화 고딕"/>
+                <a:cs typeface="무궁화 고딕"/>
+                <a:sym typeface="무궁화 고딕"/>
               </a:rPr>
               <a:t>원으로 모이기</a:t>
             </a:r>
@@ -3452,10 +3448,10 @@
                           <a:solidFill>
                             <a:srgbClr val="000000"/>
                           </a:solidFill>
-                          <a:latin typeface="Jua"/>
-                          <a:ea typeface="Jua"/>
-                          <a:cs typeface="Jua"/>
-                          <a:sym typeface="Jua"/>
+                          <a:latin typeface="무궁화 고딕"/>
+                          <a:ea typeface="무궁화 고딕"/>
+                          <a:cs typeface="무궁화 고딕"/>
+                          <a:sym typeface="무궁화 고딕"/>
                         </a:rPr>
                         <a:t>무</a:t>
                       </a:r>
@@ -3517,10 +3513,10 @@
                           <a:solidFill>
                             <a:srgbClr val="000000"/>
                           </a:solidFill>
-                          <a:latin typeface="Jua"/>
-                          <a:ea typeface="Jua"/>
-                          <a:cs typeface="Jua"/>
-                          <a:sym typeface="Jua"/>
+                          <a:latin typeface="무궁화 고딕"/>
+                          <a:ea typeface="무궁화 고딕"/>
+                          <a:cs typeface="무궁화 고딕"/>
+                          <a:sym typeface="무궁화 고딕"/>
                         </a:rPr>
                         <a:t>동</a:t>
                       </a:r>
@@ -3582,10 +3578,10 @@
                           <a:solidFill>
                             <a:srgbClr val="000000"/>
                           </a:solidFill>
-                          <a:latin typeface="Jua"/>
-                          <a:ea typeface="Jua"/>
-                          <a:cs typeface="Jua"/>
-                          <a:sym typeface="Jua"/>
+                          <a:latin typeface="무궁화 고딕"/>
+                          <a:ea typeface="무궁화 고딕"/>
+                          <a:cs typeface="무궁화 고딕"/>
+                          <a:sym typeface="무궁화 고딕"/>
                         </a:rPr>
                         <a:t>깨</a:t>
                       </a:r>
@@ -3649,10 +3645,10 @@
                           <a:solidFill>
                             <a:srgbClr val="000000"/>
                           </a:solidFill>
-                          <a:latin typeface="Jua"/>
-                          <a:ea typeface="Jua"/>
-                          <a:cs typeface="Jua"/>
-                          <a:sym typeface="Jua"/>
+                          <a:latin typeface="무궁화 고딕"/>
+                          <a:ea typeface="무궁화 고딕"/>
+                          <a:cs typeface="무궁화 고딕"/>
+                          <a:sym typeface="무궁화 고딕"/>
                         </a:rPr>
                         <a:t>하</a:t>
                       </a:r>
@@ -3714,10 +3710,10 @@
                           <a:solidFill>
                             <a:srgbClr val="000000"/>
                           </a:solidFill>
-                          <a:latin typeface="Jua"/>
-                          <a:ea typeface="Jua"/>
-                          <a:cs typeface="Jua"/>
-                          <a:sym typeface="Jua"/>
+                          <a:latin typeface="무궁화 고딕"/>
+                          <a:ea typeface="무궁화 고딕"/>
+                          <a:cs typeface="무궁화 고딕"/>
+                          <a:sym typeface="무궁화 고딕"/>
                         </a:rPr>
                         <a:t>어</a:t>
                       </a:r>
@@ -3779,10 +3775,10 @@
                           <a:solidFill>
                             <a:srgbClr val="000000"/>
                           </a:solidFill>
-                          <a:latin typeface="Jua"/>
-                          <a:ea typeface="Jua"/>
-                          <a:cs typeface="Jua"/>
-                          <a:sym typeface="Jua"/>
+                          <a:latin typeface="무궁화 고딕"/>
+                          <a:ea typeface="무궁화 고딕"/>
+                          <a:cs typeface="무궁화 고딕"/>
+                          <a:sym typeface="무궁화 고딕"/>
                         </a:rPr>
                         <a:t>기</a:t>
                       </a:r>
@@ -3923,8 +3919,8 @@
         </p:nvSpPr>
         <p:spPr>
           <a:xfrm rot="0">
-            <a:off x="2717556" y="3895725"/>
-            <a:ext cx="12852888" cy="2200275"/>
+            <a:off x="2717556" y="4181475"/>
+            <a:ext cx="12852888" cy="1914525"/>
           </a:xfrm>
           <a:prstGeom prst="rect">
             <a:avLst/>
@@ -3946,10 +3942,10 @@
                 <a:solidFill>
                   <a:srgbClr val="000000"/>
                 </a:solidFill>
-                <a:latin typeface="Jua"/>
-                <a:ea typeface="Jua"/>
-                <a:cs typeface="Jua"/>
-                <a:sym typeface="Jua"/>
+                <a:latin typeface="무궁화 고딕"/>
+                <a:ea typeface="무궁화 고딕"/>
+                <a:cs typeface="무궁화 고딕"/>
+                <a:sym typeface="무궁화 고딕"/>
               </a:rPr>
               <a:t>어깨동무하기</a:t>
             </a:r>
@@ -4027,10 +4023,10 @@
                           <a:solidFill>
                             <a:srgbClr val="000000"/>
                           </a:solidFill>
-                          <a:latin typeface="Jua"/>
-                          <a:ea typeface="Jua"/>
-                          <a:cs typeface="Jua"/>
-                          <a:sym typeface="Jua"/>
+                          <a:latin typeface="무궁화 고딕"/>
+                          <a:ea typeface="무궁화 고딕"/>
+                          <a:cs typeface="무궁화 고딕"/>
+                          <a:sym typeface="무궁화 고딕"/>
                         </a:rPr>
                         <a:t>임</a:t>
                       </a:r>
@@ -4092,10 +4088,10 @@
                           <a:solidFill>
                             <a:srgbClr val="000000"/>
                           </a:solidFill>
-                          <a:latin typeface="Jua"/>
-                          <a:ea typeface="Jua"/>
-                          <a:cs typeface="Jua"/>
-                          <a:sym typeface="Jua"/>
+                          <a:latin typeface="무궁화 고딕"/>
+                          <a:ea typeface="무궁화 고딕"/>
+                          <a:cs typeface="무궁화 고딕"/>
+                          <a:sym typeface="무궁화 고딕"/>
                         </a:rPr>
                         <a:t>완</a:t>
                       </a:r>
@@ -4157,10 +4153,10 @@
                           <a:solidFill>
                             <a:srgbClr val="000000"/>
                           </a:solidFill>
-                          <a:latin typeface="Jua"/>
-                          <a:ea typeface="Jua"/>
-                          <a:cs typeface="Jua"/>
-                          <a:sym typeface="Jua"/>
+                          <a:latin typeface="무궁화 고딕"/>
+                          <a:ea typeface="무궁화 고딕"/>
+                          <a:cs typeface="무궁화 고딕"/>
+                          <a:sym typeface="무궁화 고딕"/>
                         </a:rPr>
                         <a:t>치</a:t>
                       </a:r>
@@ -4222,10 +4218,10 @@
                           <a:solidFill>
                             <a:srgbClr val="000000"/>
                           </a:solidFill>
-                          <a:latin typeface="Jua"/>
-                          <a:ea typeface="Jua"/>
-                          <a:cs typeface="Jua"/>
-                          <a:sym typeface="Jua"/>
+                          <a:latin typeface="무궁화 고딕"/>
+                          <a:ea typeface="무궁화 고딕"/>
+                          <a:cs typeface="무궁화 고딕"/>
+                          <a:sym typeface="무궁화 고딕"/>
                         </a:rPr>
                         <a:t>하</a:t>
                       </a:r>
@@ -4289,10 +4285,10 @@
                           <a:solidFill>
                             <a:srgbClr val="000000"/>
                           </a:solidFill>
-                          <a:latin typeface="Jua"/>
-                          <a:ea typeface="Jua"/>
-                          <a:cs typeface="Jua"/>
-                          <a:sym typeface="Jua"/>
+                          <a:latin typeface="무궁화 고딕"/>
+                          <a:ea typeface="무궁화 고딕"/>
+                          <a:cs typeface="무궁화 고딕"/>
+                          <a:sym typeface="무궁화 고딕"/>
                         </a:rPr>
                         <a:t>기</a:t>
                       </a:r>
@@ -4354,10 +4350,10 @@
                           <a:solidFill>
                             <a:srgbClr val="000000"/>
                           </a:solidFill>
-                          <a:latin typeface="Jua"/>
-                          <a:ea typeface="Jua"/>
-                          <a:cs typeface="Jua"/>
-                          <a:sym typeface="Jua"/>
+                          <a:latin typeface="무궁화 고딕"/>
+                          <a:ea typeface="무궁화 고딕"/>
+                          <a:cs typeface="무궁화 고딕"/>
+                          <a:sym typeface="무궁화 고딕"/>
                         </a:rPr>
                         <a:t>눈</a:t>
                       </a:r>
@@ -4419,10 +4415,10 @@
                           <a:solidFill>
                             <a:srgbClr val="000000"/>
                           </a:solidFill>
-                          <a:latin typeface="Jua"/>
-                          <a:ea typeface="Jua"/>
-                          <a:cs typeface="Jua"/>
-                          <a:sym typeface="Jua"/>
+                          <a:latin typeface="무궁화 고딕"/>
+                          <a:ea typeface="무궁화 고딕"/>
+                          <a:cs typeface="무궁화 고딕"/>
+                          <a:sym typeface="무궁화 고딕"/>
                         </a:rPr>
                         <a:t>게</a:t>
                       </a:r>
@@ -4484,10 +4480,10 @@
                           <a:solidFill>
                             <a:srgbClr val="000000"/>
                           </a:solidFill>
-                          <a:latin typeface="Jua"/>
-                          <a:ea typeface="Jua"/>
-                          <a:cs typeface="Jua"/>
-                          <a:sym typeface="Jua"/>
+                          <a:latin typeface="무궁화 고딕"/>
+                          <a:ea typeface="무궁화 고딕"/>
+                          <a:cs typeface="무궁화 고딕"/>
+                          <a:sym typeface="무궁화 고딕"/>
                         </a:rPr>
                         <a:t>주</a:t>
                       </a:r>
@@ -4628,8 +4624,8 @@
         </p:nvSpPr>
         <p:spPr>
           <a:xfrm rot="0">
-            <a:off x="2717556" y="3895725"/>
-            <a:ext cx="12852888" cy="2200275"/>
+            <a:off x="2717556" y="4181475"/>
+            <a:ext cx="12852888" cy="1914525"/>
           </a:xfrm>
           <a:prstGeom prst="rect">
             <a:avLst/>
@@ -4651,10 +4647,10 @@
                 <a:solidFill>
                   <a:srgbClr val="000000"/>
                 </a:solidFill>
-                <a:latin typeface="Jua"/>
-                <a:ea typeface="Jua"/>
-                <a:cs typeface="Jua"/>
-                <a:sym typeface="Jua"/>
+                <a:latin typeface="무궁화 고딕"/>
+                <a:ea typeface="무궁화 고딕"/>
+                <a:cs typeface="무궁화 고딕"/>
+                <a:sym typeface="무궁화 고딕"/>
               </a:rPr>
               <a:t>눈치게임 완주하기</a:t>
             </a:r>
@@ -4731,10 +4727,10 @@
                           <a:solidFill>
                             <a:srgbClr val="000000"/>
                           </a:solidFill>
-                          <a:latin typeface="Jua"/>
-                          <a:ea typeface="Jua"/>
-                          <a:cs typeface="Jua"/>
-                          <a:sym typeface="Jua"/>
+                          <a:latin typeface="무궁화 고딕"/>
+                          <a:ea typeface="무궁화 고딕"/>
+                          <a:cs typeface="무궁화 고딕"/>
+                          <a:sym typeface="무궁화 고딕"/>
                         </a:rPr>
                         <a:t>기</a:t>
                       </a:r>
@@ -4796,10 +4792,10 @@
                           <a:solidFill>
                             <a:srgbClr val="000000"/>
                           </a:solidFill>
-                          <a:latin typeface="Jua"/>
-                          <a:ea typeface="Jua"/>
-                          <a:cs typeface="Jua"/>
-                          <a:sym typeface="Jua"/>
+                          <a:latin typeface="무궁화 고딕"/>
+                          <a:ea typeface="무궁화 고딕"/>
+                          <a:cs typeface="무궁화 고딕"/>
+                          <a:sym typeface="무궁화 고딕"/>
                         </a:rPr>
                         <a:t>한</a:t>
                       </a:r>
@@ -4861,10 +4857,10 @@
                           <a:solidFill>
                             <a:srgbClr val="000000"/>
                           </a:solidFill>
-                          <a:latin typeface="Jua"/>
-                          <a:ea typeface="Jua"/>
-                          <a:cs typeface="Jua"/>
-                          <a:sym typeface="Jua"/>
+                          <a:latin typeface="무궁화 고딕"/>
+                          <a:ea typeface="무궁화 고딕"/>
+                          <a:cs typeface="무궁화 고딕"/>
+                          <a:sym typeface="무궁화 고딕"/>
                         </a:rPr>
                         <a:t>잇</a:t>
                       </a:r>
@@ -4928,10 +4924,10 @@
                           <a:solidFill>
                             <a:srgbClr val="000000"/>
                           </a:solidFill>
-                          <a:latin typeface="Jua"/>
-                          <a:ea typeface="Jua"/>
-                          <a:cs typeface="Jua"/>
-                          <a:sym typeface="Jua"/>
+                          <a:latin typeface="무궁화 고딕"/>
+                          <a:ea typeface="무궁화 고딕"/>
+                          <a:cs typeface="무궁화 고딕"/>
+                          <a:sym typeface="무궁화 고딕"/>
                         </a:rPr>
                         <a:t>바</a:t>
                       </a:r>
@@ -4993,10 +4989,10 @@
                           <a:solidFill>
                             <a:srgbClr val="000000"/>
                           </a:solidFill>
-                          <a:latin typeface="Jua"/>
-                          <a:ea typeface="Jua"/>
-                          <a:cs typeface="Jua"/>
-                          <a:sym typeface="Jua"/>
+                          <a:latin typeface="무궁화 고딕"/>
+                          <a:ea typeface="무궁화 고딕"/>
+                          <a:cs typeface="무궁화 고딕"/>
+                          <a:sym typeface="무궁화 고딕"/>
                         </a:rPr>
                         <a:t>말</a:t>
                       </a:r>
@@ -5058,10 +5054,10 @@
                           <a:solidFill>
                             <a:srgbClr val="000000"/>
                           </a:solidFill>
-                          <a:latin typeface="Jua"/>
-                          <a:ea typeface="Jua"/>
-                          <a:cs typeface="Jua"/>
-                          <a:sym typeface="Jua"/>
+                          <a:latin typeface="무궁화 고딕"/>
+                          <a:ea typeface="무궁화 고딕"/>
+                          <a:cs typeface="무궁화 고딕"/>
+                          <a:sym typeface="무궁화 고딕"/>
                         </a:rPr>
                         <a:t>돌</a:t>
                       </a:r>
@@ -5125,10 +5121,10 @@
                           <a:solidFill>
                             <a:srgbClr val="000000"/>
                           </a:solidFill>
-                          <a:latin typeface="Jua"/>
-                          <a:ea typeface="Jua"/>
-                          <a:cs typeface="Jua"/>
-                          <a:sym typeface="Jua"/>
+                          <a:latin typeface="무궁화 고딕"/>
+                          <a:ea typeface="무궁화 고딕"/>
+                          <a:cs typeface="무궁화 고딕"/>
+                          <a:sym typeface="무궁화 고딕"/>
                         </a:rPr>
                         <a:t>끝</a:t>
                       </a:r>
@@ -5190,10 +5186,10 @@
                           <a:solidFill>
                             <a:srgbClr val="000000"/>
                           </a:solidFill>
-                          <a:latin typeface="Jua"/>
-                          <a:ea typeface="Jua"/>
-                          <a:cs typeface="Jua"/>
-                          <a:sym typeface="Jua"/>
+                          <a:latin typeface="무궁화 고딕"/>
+                          <a:ea typeface="무궁화 고딕"/>
+                          <a:cs typeface="무궁화 고딕"/>
+                          <a:sym typeface="무궁화 고딕"/>
                         </a:rPr>
                         <a:t>퀴</a:t>
                       </a:r>
@@ -5255,10 +5251,10 @@
                           <a:solidFill>
                             <a:srgbClr val="000000"/>
                           </a:solidFill>
-                          <a:latin typeface="Jua"/>
-                          <a:ea typeface="Jua"/>
-                          <a:cs typeface="Jua"/>
-                          <a:sym typeface="Jua"/>
+                          <a:latin typeface="무궁화 고딕"/>
+                          <a:ea typeface="무궁화 고딕"/>
+                          <a:cs typeface="무궁화 고딕"/>
+                          <a:sym typeface="무궁화 고딕"/>
                         </a:rPr>
                         <a:t>기</a:t>
                       </a:r>
@@ -5399,8 +5395,8 @@
         </p:nvSpPr>
         <p:spPr>
           <a:xfrm rot="0">
-            <a:off x="2717556" y="3895725"/>
-            <a:ext cx="12852888" cy="2200275"/>
+            <a:off x="2717556" y="4219575"/>
+            <a:ext cx="12852888" cy="1838325"/>
           </a:xfrm>
           <a:prstGeom prst="rect">
             <a:avLst/>
@@ -5414,18 +5410,18 @@
           <a:p>
             <a:pPr algn="ctr">
               <a:lnSpc>
-                <a:spcPts val="15000"/>
+                <a:spcPts val="14400"/>
               </a:lnSpc>
             </a:pPr>
             <a:r>
-              <a:rPr lang="en-US" sz="12500">
+              <a:rPr lang="en-US" sz="12000">
                 <a:solidFill>
                   <a:srgbClr val="000000"/>
                 </a:solidFill>
-                <a:latin typeface="Jua"/>
-                <a:ea typeface="Jua"/>
-                <a:cs typeface="Jua"/>
-                <a:sym typeface="Jua"/>
+                <a:latin typeface="무궁화 고딕"/>
+                <a:ea typeface="무궁화 고딕"/>
+                <a:cs typeface="무궁화 고딕"/>
+                <a:sym typeface="무궁화 고딕"/>
               </a:rPr>
               <a:t>끝말잇기 한바퀴 돌기</a:t>
             </a:r>
@@ -5502,10 +5498,10 @@
                           <a:solidFill>
                             <a:srgbClr val="000000"/>
                           </a:solidFill>
-                          <a:latin typeface="Jua"/>
-                          <a:ea typeface="Jua"/>
-                          <a:cs typeface="Jua"/>
-                          <a:sym typeface="Jua"/>
+                          <a:latin typeface="무궁화 고딕"/>
+                          <a:ea typeface="무궁화 고딕"/>
+                          <a:cs typeface="무궁화 고딕"/>
+                          <a:sym typeface="무궁화 고딕"/>
                         </a:rPr>
                         <a:t>한</a:t>
                       </a:r>
@@ -5567,10 +5563,10 @@
                           <a:solidFill>
                             <a:srgbClr val="000000"/>
                           </a:solidFill>
-                          <a:latin typeface="Jua"/>
-                          <a:ea typeface="Jua"/>
-                          <a:cs typeface="Jua"/>
-                          <a:sym typeface="Jua"/>
+                          <a:latin typeface="무궁화 고딕"/>
+                          <a:ea typeface="무궁화 고딕"/>
+                          <a:cs typeface="무궁화 고딕"/>
+                          <a:sym typeface="무궁화 고딕"/>
                         </a:rPr>
                         <a:t>티</a:t>
                       </a:r>
@@ -5632,10 +5628,10 @@
                           <a:solidFill>
                             <a:srgbClr val="000000"/>
                           </a:solidFill>
-                          <a:latin typeface="Jua"/>
-                          <a:ea typeface="Jua"/>
-                          <a:cs typeface="Jua"/>
-                          <a:sym typeface="Jua"/>
+                          <a:latin typeface="무궁화 고딕"/>
+                          <a:ea typeface="무궁화 고딕"/>
+                          <a:cs typeface="무궁화 고딕"/>
+                          <a:sym typeface="무궁화 고딕"/>
                         </a:rPr>
                         <a:t>기</a:t>
                       </a:r>
@@ -5699,10 +5695,10 @@
                           <a:solidFill>
                             <a:srgbClr val="000000"/>
                           </a:solidFill>
-                          <a:latin typeface="Jua"/>
-                          <a:ea typeface="Jua"/>
-                          <a:cs typeface="Jua"/>
-                          <a:sym typeface="Jua"/>
+                          <a:latin typeface="무궁화 고딕"/>
+                          <a:ea typeface="무궁화 고딕"/>
+                          <a:cs typeface="무궁화 고딕"/>
+                          <a:sym typeface="무궁화 고딕"/>
                         </a:rPr>
                         <a:t>버</a:t>
                       </a:r>
@@ -5764,10 +5760,10 @@
                           <a:solidFill>
                             <a:srgbClr val="000000"/>
                           </a:solidFill>
-                          <a:latin typeface="Jua"/>
-                          <a:ea typeface="Jua"/>
-                          <a:cs typeface="Jua"/>
-                          <a:sym typeface="Jua"/>
+                          <a:latin typeface="무궁화 고딕"/>
+                          <a:ea typeface="무궁화 고딕"/>
+                          <a:cs typeface="무궁화 고딕"/>
+                          <a:sym typeface="무궁화 고딕"/>
                         </a:rPr>
                         <a:t>발</a:t>
                       </a:r>
@@ -5829,10 +5825,10 @@
                           <a:solidFill>
                             <a:srgbClr val="000000"/>
                           </a:solidFill>
-                          <a:latin typeface="Jua"/>
-                          <a:ea typeface="Jua"/>
-                          <a:cs typeface="Jua"/>
-                          <a:sym typeface="Jua"/>
+                          <a:latin typeface="무궁화 고딕"/>
+                          <a:ea typeface="무궁화 고딕"/>
+                          <a:cs typeface="무궁화 고딕"/>
+                          <a:sym typeface="무궁화 고딕"/>
                         </a:rPr>
                         <a:t>로</a:t>
                       </a:r>
@@ -5896,10 +5892,10 @@
                           <a:solidFill>
                             <a:srgbClr val="000000"/>
                           </a:solidFill>
-                          <a:latin typeface="Jua"/>
-                          <a:ea typeface="Jua"/>
-                          <a:cs typeface="Jua"/>
-                          <a:sym typeface="Jua"/>
+                          <a:latin typeface="무궁화 고딕"/>
+                          <a:ea typeface="무궁화 고딕"/>
+                          <a:cs typeface="무궁화 고딕"/>
+                          <a:sym typeface="무궁화 고딕"/>
                         </a:rPr>
                         <a:t>십</a:t>
                       </a:r>
@@ -5961,10 +5957,10 @@
                           <a:solidFill>
                             <a:srgbClr val="000000"/>
                           </a:solidFill>
-                          <a:latin typeface="Jua"/>
-                          <a:ea typeface="Jua"/>
-                          <a:cs typeface="Jua"/>
-                          <a:sym typeface="Jua"/>
+                          <a:latin typeface="무궁화 고딕"/>
+                          <a:ea typeface="무궁화 고딕"/>
+                          <a:cs typeface="무궁화 고딕"/>
+                          <a:sym typeface="무궁화 고딕"/>
                         </a:rPr>
                         <a:t>초</a:t>
                       </a:r>
@@ -6026,10 +6022,10 @@
                           <a:solidFill>
                             <a:srgbClr val="000000"/>
                           </a:solidFill>
-                          <a:latin typeface="Jua"/>
-                          <a:ea typeface="Jua"/>
-                          <a:cs typeface="Jua"/>
-                          <a:sym typeface="Jua"/>
+                          <a:latin typeface="무궁화 고딕"/>
+                          <a:ea typeface="무궁화 고딕"/>
+                          <a:cs typeface="무궁화 고딕"/>
+                          <a:sym typeface="무궁화 고딕"/>
                         </a:rPr>
                         <a:t>간</a:t>
                       </a:r>
@@ -6170,8 +6166,8 @@
         </p:nvSpPr>
         <p:spPr>
           <a:xfrm rot="0">
-            <a:off x="2717556" y="3895725"/>
-            <a:ext cx="12852888" cy="2200275"/>
+            <a:off x="2717556" y="4238625"/>
+            <a:ext cx="12852888" cy="1800225"/>
           </a:xfrm>
           <a:prstGeom prst="rect">
             <a:avLst/>
@@ -6185,18 +6181,18 @@
           <a:p>
             <a:pPr algn="ctr">
               <a:lnSpc>
-                <a:spcPts val="15000"/>
+                <a:spcPts val="14160"/>
               </a:lnSpc>
             </a:pPr>
             <a:r>
-              <a:rPr lang="en-US" sz="12500">
+              <a:rPr lang="en-US" sz="11800">
                 <a:solidFill>
                   <a:srgbClr val="000000"/>
                 </a:solidFill>
-                <a:latin typeface="Jua"/>
-                <a:ea typeface="Jua"/>
-                <a:cs typeface="Jua"/>
-                <a:sym typeface="Jua"/>
+                <a:latin typeface="무궁화 고딕"/>
+                <a:ea typeface="무궁화 고딕"/>
+                <a:cs typeface="무궁화 고딕"/>
+                <a:sym typeface="무궁화 고딕"/>
               </a:rPr>
               <a:t>한발로 십초간 버티기</a:t>
             </a:r>
@@ -6273,10 +6269,10 @@
                           <a:solidFill>
                             <a:srgbClr val="000000"/>
                           </a:solidFill>
-                          <a:latin typeface="Jua"/>
-                          <a:ea typeface="Jua"/>
-                          <a:cs typeface="Jua"/>
-                          <a:sym typeface="Jua"/>
+                          <a:latin typeface="무궁화 고딕"/>
+                          <a:ea typeface="무궁화 고딕"/>
+                          <a:cs typeface="무궁화 고딕"/>
+                          <a:sym typeface="무궁화 고딕"/>
                         </a:rPr>
                         <a:t>부</a:t>
                       </a:r>
@@ -6338,10 +6334,10 @@
                           <a:solidFill>
                             <a:srgbClr val="000000"/>
                           </a:solidFill>
-                          <a:latin typeface="Jua"/>
-                          <a:ea typeface="Jua"/>
-                          <a:cs typeface="Jua"/>
-                          <a:sym typeface="Jua"/>
+                          <a:latin typeface="무궁화 고딕"/>
+                          <a:ea typeface="무궁화 고딕"/>
+                          <a:cs typeface="무궁화 고딕"/>
+                          <a:sym typeface="무궁화 고딕"/>
                         </a:rPr>
                         <a:t>전</a:t>
                       </a:r>
@@ -6403,10 +6399,10 @@
                           <a:solidFill>
                             <a:srgbClr val="000000"/>
                           </a:solidFill>
-                          <a:latin typeface="Jua"/>
-                          <a:ea typeface="Jua"/>
-                          <a:cs typeface="Jua"/>
-                          <a:sym typeface="Jua"/>
+                          <a:latin typeface="무궁화 고딕"/>
+                          <a:ea typeface="무궁화 고딕"/>
+                          <a:cs typeface="무궁화 고딕"/>
+                          <a:sym typeface="무궁화 고딕"/>
                         </a:rPr>
                         <a:t>대</a:t>
                       </a:r>
@@ -6470,10 +6466,10 @@
                           <a:solidFill>
                             <a:srgbClr val="000000"/>
                           </a:solidFill>
-                          <a:latin typeface="Jua"/>
-                          <a:ea typeface="Jua"/>
-                          <a:cs typeface="Jua"/>
-                          <a:sym typeface="Jua"/>
+                          <a:latin typeface="무궁화 고딕"/>
+                          <a:ea typeface="무궁화 고딕"/>
+                          <a:cs typeface="무궁화 고딕"/>
+                          <a:sym typeface="무궁화 고딕"/>
                         </a:rPr>
                         <a:t>등</a:t>
                       </a:r>
@@ -6535,10 +6531,10 @@
                           <a:solidFill>
                             <a:srgbClr val="000000"/>
                           </a:solidFill>
-                          <a:latin typeface="Jua"/>
-                          <a:ea typeface="Jua"/>
-                          <a:cs typeface="Jua"/>
-                          <a:sym typeface="Jua"/>
+                          <a:latin typeface="무궁화 고딕"/>
+                          <a:ea typeface="무궁화 고딕"/>
+                          <a:cs typeface="무궁화 고딕"/>
+                          <a:sym typeface="무궁화 고딕"/>
                         </a:rPr>
                         <a:t>팀</a:t>
                       </a:r>
@@ -6600,10 +6596,10 @@
                           <a:solidFill>
                             <a:srgbClr val="000000"/>
                           </a:solidFill>
-                          <a:latin typeface="Jua"/>
-                          <a:ea typeface="Jua"/>
-                          <a:cs typeface="Jua"/>
-                          <a:sym typeface="Jua"/>
+                          <a:latin typeface="무궁화 고딕"/>
+                          <a:ea typeface="무궁화 고딕"/>
+                          <a:cs typeface="무궁화 고딕"/>
+                          <a:sym typeface="무궁화 고딕"/>
                         </a:rPr>
                         <a:t>원</a:t>
                       </a:r>
@@ -6667,10 +6663,10 @@
                           <a:solidFill>
                             <a:srgbClr val="000000"/>
                           </a:solidFill>
-                          <a:latin typeface="Jua"/>
-                          <a:ea typeface="Jua"/>
-                          <a:cs typeface="Jua"/>
-                          <a:sym typeface="Jua"/>
+                          <a:latin typeface="무궁화 고딕"/>
+                          <a:ea typeface="무궁화 고딕"/>
+                          <a:cs typeface="무궁화 고딕"/>
+                          <a:sym typeface="무궁화 고딕"/>
                         </a:rPr>
                         <a:t>기</a:t>
                       </a:r>
@@ -6732,10 +6728,10 @@
                           <a:solidFill>
                             <a:srgbClr val="000000"/>
                           </a:solidFill>
-                          <a:latin typeface="Jua"/>
-                          <a:ea typeface="Jua"/>
-                          <a:cs typeface="Jua"/>
-                          <a:sym typeface="Jua"/>
+                          <a:latin typeface="무궁화 고딕"/>
+                          <a:ea typeface="무궁화 고딕"/>
+                          <a:cs typeface="무궁화 고딕"/>
+                          <a:sym typeface="무궁화 고딕"/>
                         </a:rPr>
                         <a:t>앉</a:t>
                       </a:r>
@@ -6797,10 +6793,10 @@
                           <a:solidFill>
                             <a:srgbClr val="000000"/>
                           </a:solidFill>
-                          <a:latin typeface="Jua"/>
-                          <a:ea typeface="Jua"/>
-                          <a:cs typeface="Jua"/>
-                          <a:sym typeface="Jua"/>
+                          <a:latin typeface="무궁화 고딕"/>
+                          <a:ea typeface="무궁화 고딕"/>
+                          <a:cs typeface="무궁화 고딕"/>
+                          <a:sym typeface="무궁화 고딕"/>
                         </a:rPr>
                         <a:t>고</a:t>
                       </a:r>
@@ -6993,8 +6989,8 @@
         </p:nvSpPr>
         <p:spPr>
           <a:xfrm rot="0">
-            <a:off x="11392761" y="600705"/>
-            <a:ext cx="5362043" cy="1600200"/>
+            <a:off x="11392761" y="819780"/>
+            <a:ext cx="5362043" cy="1381125"/>
           </a:xfrm>
           <a:prstGeom prst="rect">
             <a:avLst/>
@@ -7016,10 +7012,10 @@
                 <a:solidFill>
                   <a:srgbClr val="FFFAEF"/>
                 </a:solidFill>
-                <a:latin typeface="Jua"/>
-                <a:ea typeface="Jua"/>
-                <a:cs typeface="Jua"/>
-                <a:sym typeface="Jua"/>
+                <a:latin typeface="무궁화 고딕"/>
+                <a:ea typeface="무궁화 고딕"/>
+                <a:cs typeface="무궁화 고딕"/>
+                <a:sym typeface="무궁화 고딕"/>
               </a:rPr>
               <a:t>규칙</a:t>
             </a:r>
@@ -7035,9 +7031,9 @@
         <p:grpSpPr>
           <a:xfrm rot="0">
             <a:off x="309172" y="535073"/>
-            <a:ext cx="10694683" cy="2573620"/>
+            <a:ext cx="10694683" cy="2406534"/>
             <a:chOff x="0" y="0"/>
-            <a:chExt cx="14259577" cy="3431493"/>
+            <a:chExt cx="14259577" cy="3208711"/>
           </a:xfrm>
         </p:grpSpPr>
         <p:sp>
@@ -7048,8 +7044,8 @@
           </p:nvSpPr>
           <p:spPr>
             <a:xfrm rot="0">
-              <a:off x="0" y="1380584"/>
-              <a:ext cx="14259577" cy="2050910"/>
+              <a:off x="0" y="1388378"/>
+              <a:ext cx="14259577" cy="1820333"/>
             </a:xfrm>
             <a:prstGeom prst="rect">
               <a:avLst/>
@@ -7063,18 +7059,18 @@
             <a:p>
               <a:pPr algn="l">
                 <a:lnSpc>
-                  <a:spcPts val="6273"/>
+                  <a:spcPts val="5599"/>
                 </a:lnSpc>
               </a:pPr>
               <a:r>
-                <a:rPr lang="en-US" sz="4480">
+                <a:rPr lang="en-US" sz="3999">
                   <a:solidFill>
                     <a:srgbClr val="FFFAEF"/>
                   </a:solidFill>
-                  <a:latin typeface="TDTD가온"/>
-                  <a:ea typeface="TDTD가온"/>
-                  <a:cs typeface="TDTD가온"/>
-                  <a:sym typeface="TDTD가온"/>
+                  <a:latin typeface="무궁화 고딕"/>
+                  <a:ea typeface="무궁화 고딕"/>
+                  <a:cs typeface="무궁화 고딕"/>
+                  <a:sym typeface="무궁화 고딕"/>
                 </a:rPr>
                 <a:t>화면에 글자가 섞인 격자판이 나타납니다.</a:t>
               </a:r>
@@ -7082,18 +7078,18 @@
             <a:p>
               <a:pPr algn="l">
                 <a:lnSpc>
-                  <a:spcPts val="6273"/>
+                  <a:spcPts val="5599"/>
                 </a:lnSpc>
               </a:pPr>
               <a:r>
-                <a:rPr lang="en-US" sz="4480">
+                <a:rPr lang="en-US" sz="3999">
                   <a:solidFill>
                     <a:srgbClr val="FFFAEF"/>
                   </a:solidFill>
-                  <a:latin typeface="TDTD가온"/>
-                  <a:ea typeface="TDTD가온"/>
-                  <a:cs typeface="TDTD가온"/>
-                  <a:sym typeface="TDTD가온"/>
+                  <a:latin typeface="무궁화 고딕"/>
+                  <a:ea typeface="무궁화 고딕"/>
+                  <a:cs typeface="무궁화 고딕"/>
+                  <a:sym typeface="무궁화 고딕"/>
                 </a:rPr>
                 <a:t>글자를 조합하여 숨겨진 지령을 알아내세요.</a:t>
               </a:r>
@@ -7108,8 +7104,8 @@
           </p:nvSpPr>
           <p:spPr>
             <a:xfrm rot="0">
-              <a:off x="0" y="-171450"/>
-              <a:ext cx="9574913" cy="1169217"/>
+              <a:off x="0" y="-66675"/>
+              <a:ext cx="9574913" cy="1062712"/>
             </a:xfrm>
             <a:prstGeom prst="rect">
               <a:avLst/>
@@ -7131,10 +7127,10 @@
                   <a:solidFill>
                     <a:srgbClr val="FFFAEF"/>
                   </a:solidFill>
-                  <a:latin typeface="Jua"/>
-                  <a:ea typeface="Jua"/>
-                  <a:cs typeface="Jua"/>
-                  <a:sym typeface="Jua"/>
+                  <a:latin typeface="무궁화 고딕 Bold"/>
+                  <a:ea typeface="무궁화 고딕 Bold"/>
+                  <a:cs typeface="무궁화 고딕 Bold"/>
+                  <a:sym typeface="무궁화 고딕 Bold"/>
                 </a:rPr>
                 <a:t>STEP 1.</a:t>
               </a:r>
@@ -7150,10 +7146,10 @@
         </p:nvGrpSpPr>
         <p:grpSpPr>
           <a:xfrm rot="0">
-            <a:off x="10281405" y="7350840"/>
-            <a:ext cx="7584755" cy="2574122"/>
+            <a:off x="10281405" y="7511261"/>
+            <a:ext cx="7584755" cy="2402712"/>
             <a:chOff x="0" y="0"/>
-            <a:chExt cx="10113007" cy="3432162"/>
+            <a:chExt cx="10113007" cy="3203616"/>
           </a:xfrm>
         </p:grpSpPr>
         <p:sp>
@@ -7164,8 +7160,8 @@
           </p:nvSpPr>
           <p:spPr>
             <a:xfrm rot="0">
-              <a:off x="0" y="1377534"/>
-              <a:ext cx="9958397" cy="2054628"/>
+              <a:off x="0" y="1373758"/>
+              <a:ext cx="9958397" cy="1829858"/>
             </a:xfrm>
             <a:prstGeom prst="rect">
               <a:avLst/>
@@ -7179,18 +7175,18 @@
             <a:p>
               <a:pPr algn="l">
                 <a:lnSpc>
-                  <a:spcPts val="6284"/>
+                  <a:spcPts val="5600"/>
                 </a:lnSpc>
               </a:pPr>
               <a:r>
-                <a:rPr lang="en-US" sz="4489">
+                <a:rPr lang="en-US" sz="4000">
                   <a:solidFill>
                     <a:srgbClr val="FFFAEF"/>
                   </a:solidFill>
-                  <a:latin typeface="TDTD가온"/>
-                  <a:ea typeface="TDTD가온"/>
-                  <a:cs typeface="TDTD가온"/>
-                  <a:sym typeface="TDTD가온"/>
+                  <a:latin typeface="무궁화 고딕"/>
+                  <a:ea typeface="무궁화 고딕"/>
+                  <a:cs typeface="무궁화 고딕"/>
+                  <a:sym typeface="무궁화 고딕"/>
                 </a:rPr>
                 <a:t>1분 안에 행동을 수행한 팀이 점수!</a:t>
               </a:r>
@@ -7198,18 +7194,18 @@
             <a:p>
               <a:pPr algn="l">
                 <a:lnSpc>
-                  <a:spcPts val="6284"/>
+                  <a:spcPts val="5600"/>
                 </a:lnSpc>
               </a:pPr>
               <a:r>
-                <a:rPr lang="en-US" sz="4489">
+                <a:rPr lang="en-US" sz="4000">
                   <a:solidFill>
                     <a:srgbClr val="FFFAEF"/>
                   </a:solidFill>
-                  <a:latin typeface="TDTD가온"/>
-                  <a:ea typeface="TDTD가온"/>
-                  <a:cs typeface="TDTD가온"/>
-                  <a:sym typeface="TDTD가온"/>
+                  <a:latin typeface="무궁화 고딕"/>
+                  <a:ea typeface="무궁화 고딕"/>
+                  <a:cs typeface="무궁화 고딕"/>
+                  <a:sym typeface="무궁화 고딕"/>
                 </a:rPr>
                 <a:t>가장 많이 통과한 팀이 우승합니다.</a:t>
               </a:r>
@@ -7224,8 +7220,8 @@
           </p:nvSpPr>
           <p:spPr>
             <a:xfrm rot="0">
-              <a:off x="0" y="-171450"/>
-              <a:ext cx="10113007" cy="1171105"/>
+              <a:off x="0" y="-57150"/>
+              <a:ext cx="10113007" cy="1053029"/>
             </a:xfrm>
             <a:prstGeom prst="rect">
               <a:avLst/>
@@ -7247,10 +7243,10 @@
                   <a:solidFill>
                     <a:srgbClr val="FFFAEF"/>
                   </a:solidFill>
-                  <a:latin typeface="Jua"/>
-                  <a:ea typeface="Jua"/>
-                  <a:cs typeface="Jua"/>
-                  <a:sym typeface="Jua"/>
+                  <a:latin typeface="무궁화 고딕 Bold"/>
+                  <a:ea typeface="무궁화 고딕 Bold"/>
+                  <a:cs typeface="무궁화 고딕 Bold"/>
+                  <a:sym typeface="무궁화 고딕 Bold"/>
                 </a:rPr>
                 <a:t>STEP 3.</a:t>
               </a:r>
@@ -7266,10 +7262,10 @@
         </p:nvGrpSpPr>
         <p:grpSpPr>
           <a:xfrm rot="0">
-            <a:off x="5198474" y="3858476"/>
-            <a:ext cx="7891051" cy="2570047"/>
+            <a:off x="5078159" y="4025303"/>
+            <a:ext cx="7891051" cy="2402261"/>
             <a:chOff x="0" y="0"/>
-            <a:chExt cx="10521401" cy="3426730"/>
+            <a:chExt cx="10521401" cy="3203015"/>
           </a:xfrm>
         </p:grpSpPr>
         <p:sp>
@@ -7280,8 +7276,8 @@
           </p:nvSpPr>
           <p:spPr>
             <a:xfrm rot="0">
-              <a:off x="0" y="1375218"/>
-              <a:ext cx="10521401" cy="2051512"/>
+              <a:off x="0" y="1382681"/>
+              <a:ext cx="10521401" cy="1820333"/>
             </a:xfrm>
             <a:prstGeom prst="rect">
               <a:avLst/>
@@ -7295,18 +7291,18 @@
             <a:p>
               <a:pPr algn="l">
                 <a:lnSpc>
-                  <a:spcPts val="6275"/>
+                  <a:spcPts val="5599"/>
                 </a:lnSpc>
               </a:pPr>
               <a:r>
-                <a:rPr lang="en-US" sz="4482">
+                <a:rPr lang="en-US" sz="3999">
                   <a:solidFill>
                     <a:srgbClr val="FFFAEF"/>
                   </a:solidFill>
-                  <a:latin typeface="TDTD가온"/>
-                  <a:ea typeface="TDTD가온"/>
-                  <a:cs typeface="TDTD가온"/>
-                  <a:sym typeface="TDTD가온"/>
+                  <a:latin typeface="무궁화 고딕"/>
+                  <a:ea typeface="무궁화 고딕"/>
+                  <a:cs typeface="무궁화 고딕"/>
+                  <a:sym typeface="무궁화 고딕"/>
                 </a:rPr>
                 <a:t>정답을 입으로 말하면 안 됩니다!</a:t>
               </a:r>
@@ -7314,18 +7310,18 @@
             <a:p>
               <a:pPr algn="l">
                 <a:lnSpc>
-                  <a:spcPts val="6275"/>
+                  <a:spcPts val="5599"/>
                 </a:lnSpc>
               </a:pPr>
               <a:r>
-                <a:rPr lang="en-US" sz="4482">
+                <a:rPr lang="en-US" sz="3999">
                   <a:solidFill>
                     <a:srgbClr val="FFFAEF"/>
                   </a:solidFill>
-                  <a:latin typeface="TDTD가온"/>
-                  <a:ea typeface="TDTD가온"/>
-                  <a:cs typeface="TDTD가온"/>
-                  <a:sym typeface="TDTD가온"/>
+                  <a:latin typeface="무궁화 고딕"/>
+                  <a:ea typeface="무궁화 고딕"/>
+                  <a:cs typeface="무궁화 고딕"/>
+                  <a:sym typeface="무궁화 고딕"/>
                 </a:rPr>
                 <a:t>말 없이 해당 행동을 직접 수행하세요.</a:t>
               </a:r>
@@ -7340,8 +7336,8 @@
           </p:nvSpPr>
           <p:spPr>
             <a:xfrm rot="0">
-              <a:off x="0" y="-171450"/>
-              <a:ext cx="6486548" cy="1169523"/>
+              <a:off x="0" y="-57150"/>
+              <a:ext cx="6486548" cy="1053161"/>
             </a:xfrm>
             <a:prstGeom prst="rect">
               <a:avLst/>
@@ -7363,10 +7359,10 @@
                   <a:solidFill>
                     <a:srgbClr val="FFFAEF"/>
                   </a:solidFill>
-                  <a:latin typeface="Jua"/>
-                  <a:ea typeface="Jua"/>
-                  <a:cs typeface="Jua"/>
-                  <a:sym typeface="Jua"/>
+                  <a:latin typeface="무궁화 고딕 Bold"/>
+                  <a:ea typeface="무궁화 고딕 Bold"/>
+                  <a:cs typeface="무궁화 고딕 Bold"/>
+                  <a:sym typeface="무궁화 고딕 Bold"/>
                 </a:rPr>
                 <a:t>STEP 2.</a:t>
               </a:r>
@@ -7464,8 +7460,8 @@
         </p:nvSpPr>
         <p:spPr>
           <a:xfrm rot="0">
-            <a:off x="2717556" y="3895725"/>
-            <a:ext cx="12852888" cy="2200275"/>
+            <a:off x="2717556" y="4267200"/>
+            <a:ext cx="12852888" cy="1743075"/>
           </a:xfrm>
           <a:prstGeom prst="rect">
             <a:avLst/>
@@ -7479,18 +7475,18 @@
           <a:p>
             <a:pPr algn="ctr">
               <a:lnSpc>
-                <a:spcPts val="15000"/>
+                <a:spcPts val="13680"/>
               </a:lnSpc>
             </a:pPr>
             <a:r>
-              <a:rPr lang="en-US" sz="12500">
+              <a:rPr lang="en-US" sz="11400">
                 <a:solidFill>
                   <a:srgbClr val="000000"/>
                 </a:solidFill>
-                <a:latin typeface="Jua"/>
-                <a:ea typeface="Jua"/>
-                <a:cs typeface="Jua"/>
-                <a:sym typeface="Jua"/>
+                <a:latin typeface="무궁화 고딕"/>
+                <a:ea typeface="무궁화 고딕"/>
+                <a:cs typeface="무궁화 고딕"/>
+                <a:sym typeface="무궁화 고딕"/>
               </a:rPr>
               <a:t>팀원 전부 등대고 앉기</a:t>
             </a:r>
@@ -7567,10 +7563,10 @@
                           <a:solidFill>
                             <a:srgbClr val="000000"/>
                           </a:solidFill>
-                          <a:latin typeface="Jua"/>
-                          <a:ea typeface="Jua"/>
-                          <a:cs typeface="Jua"/>
-                          <a:sym typeface="Jua"/>
+                          <a:latin typeface="무궁화 고딕"/>
+                          <a:ea typeface="무궁화 고딕"/>
+                          <a:cs typeface="무궁화 고딕"/>
+                          <a:sym typeface="무궁화 고딕"/>
                         </a:rPr>
                         <a:t>각</a:t>
                       </a:r>
@@ -7632,10 +7628,10 @@
                           <a:solidFill>
                             <a:srgbClr val="000000"/>
                           </a:solidFill>
-                          <a:latin typeface="Jua"/>
-                          <a:ea typeface="Jua"/>
-                          <a:cs typeface="Jua"/>
-                          <a:sym typeface="Jua"/>
+                          <a:latin typeface="무궁화 고딕"/>
+                          <a:ea typeface="무궁화 고딕"/>
+                          <a:cs typeface="무궁화 고딕"/>
+                          <a:sym typeface="무궁화 고딕"/>
                         </a:rPr>
                         <a:t>팀</a:t>
                       </a:r>
@@ -7697,10 +7693,10 @@
                           <a:solidFill>
                             <a:srgbClr val="000000"/>
                           </a:solidFill>
-                          <a:latin typeface="Jua"/>
-                          <a:ea typeface="Jua"/>
-                          <a:cs typeface="Jua"/>
-                          <a:sym typeface="Jua"/>
+                          <a:latin typeface="무궁화 고딕"/>
+                          <a:ea typeface="무궁화 고딕"/>
+                          <a:cs typeface="무궁화 고딕"/>
+                          <a:sym typeface="무궁화 고딕"/>
                         </a:rPr>
                         <a:t>선</a:t>
                       </a:r>
@@ -7764,10 +7760,10 @@
                           <a:solidFill>
                             <a:srgbClr val="000000"/>
                           </a:solidFill>
-                          <a:latin typeface="Jua"/>
-                          <a:ea typeface="Jua"/>
-                          <a:cs typeface="Jua"/>
-                          <a:sym typeface="Jua"/>
+                          <a:latin typeface="무궁화 고딕"/>
+                          <a:ea typeface="무궁화 고딕"/>
+                          <a:cs typeface="무궁화 고딕"/>
+                          <a:sym typeface="무궁화 고딕"/>
                         </a:rPr>
                         <a:t>생</a:t>
                       </a:r>
@@ -7829,10 +7825,10 @@
                           <a:solidFill>
                             <a:srgbClr val="000000"/>
                           </a:solidFill>
-                          <a:latin typeface="Jua"/>
-                          <a:ea typeface="Jua"/>
-                          <a:cs typeface="Jua"/>
-                          <a:sym typeface="Jua"/>
+                          <a:latin typeface="무궁화 고딕"/>
+                          <a:ea typeface="무궁화 고딕"/>
+                          <a:cs typeface="무궁화 고딕"/>
+                          <a:sym typeface="무궁화 고딕"/>
                         </a:rPr>
                         <a:t>님</a:t>
                       </a:r>
@@ -7894,10 +7890,10 @@
                           <a:solidFill>
                             <a:srgbClr val="000000"/>
                           </a:solidFill>
-                          <a:latin typeface="Jua"/>
-                          <a:ea typeface="Jua"/>
-                          <a:cs typeface="Jua"/>
-                          <a:sym typeface="Jua"/>
+                          <a:latin typeface="무궁화 고딕"/>
+                          <a:ea typeface="무궁화 고딕"/>
+                          <a:cs typeface="무궁화 고딕"/>
+                          <a:sym typeface="무궁화 고딕"/>
                         </a:rPr>
                         <a:t>안</a:t>
                       </a:r>
@@ -7961,10 +7957,10 @@
                           <a:solidFill>
                             <a:srgbClr val="000000"/>
                           </a:solidFill>
-                          <a:latin typeface="Jua"/>
-                          <a:ea typeface="Jua"/>
-                          <a:cs typeface="Jua"/>
-                          <a:sym typeface="Jua"/>
+                          <a:latin typeface="무궁화 고딕"/>
+                          <a:ea typeface="무궁화 고딕"/>
+                          <a:cs typeface="무궁화 고딕"/>
+                          <a:sym typeface="무궁화 고딕"/>
                         </a:rPr>
                         <a:t>아</a:t>
                       </a:r>
@@ -8026,10 +8022,10 @@
                           <a:solidFill>
                             <a:srgbClr val="000000"/>
                           </a:solidFill>
-                          <a:latin typeface="Jua"/>
-                          <a:ea typeface="Jua"/>
-                          <a:cs typeface="Jua"/>
-                          <a:sym typeface="Jua"/>
+                          <a:latin typeface="무궁화 고딕"/>
+                          <a:ea typeface="무궁화 고딕"/>
+                          <a:cs typeface="무궁화 고딕"/>
+                          <a:sym typeface="무궁화 고딕"/>
                         </a:rPr>
                         <a:t>주</a:t>
                       </a:r>
@@ -8091,10 +8087,10 @@
                           <a:solidFill>
                             <a:srgbClr val="000000"/>
                           </a:solidFill>
-                          <a:latin typeface="Jua"/>
-                          <a:ea typeface="Jua"/>
-                          <a:cs typeface="Jua"/>
-                          <a:sym typeface="Jua"/>
+                          <a:latin typeface="무궁화 고딕"/>
+                          <a:ea typeface="무궁화 고딕"/>
+                          <a:cs typeface="무궁화 고딕"/>
+                          <a:sym typeface="무궁화 고딕"/>
                         </a:rPr>
                         <a:t>기</a:t>
                       </a:r>
@@ -8235,8 +8231,8 @@
         </p:nvSpPr>
         <p:spPr>
           <a:xfrm rot="0">
-            <a:off x="2717556" y="3895725"/>
-            <a:ext cx="12852888" cy="2200275"/>
+            <a:off x="2717556" y="4252913"/>
+            <a:ext cx="12852888" cy="1771650"/>
           </a:xfrm>
           <a:prstGeom prst="rect">
             <a:avLst/>
@@ -8250,18 +8246,18 @@
           <a:p>
             <a:pPr algn="ctr">
               <a:lnSpc>
-                <a:spcPts val="15000"/>
+                <a:spcPts val="13920"/>
               </a:lnSpc>
             </a:pPr>
             <a:r>
-              <a:rPr lang="en-US" sz="12500">
+              <a:rPr lang="en-US" sz="11600">
                 <a:solidFill>
                   <a:srgbClr val="000000"/>
                 </a:solidFill>
-                <a:latin typeface="Jua"/>
-                <a:ea typeface="Jua"/>
-                <a:cs typeface="Jua"/>
-                <a:sym typeface="Jua"/>
+                <a:latin typeface="무궁화 고딕"/>
+                <a:ea typeface="무궁화 고딕"/>
+                <a:cs typeface="무궁화 고딕"/>
+                <a:sym typeface="무궁화 고딕"/>
               </a:rPr>
               <a:t>각팀 선생님 안아주기</a:t>
             </a:r>
@@ -8338,10 +8334,10 @@
                           <a:solidFill>
                             <a:srgbClr val="000000"/>
                           </a:solidFill>
-                          <a:latin typeface="Jua"/>
-                          <a:ea typeface="Jua"/>
-                          <a:cs typeface="Jua"/>
-                          <a:sym typeface="Jua"/>
+                          <a:latin typeface="무궁화 고딕"/>
+                          <a:ea typeface="무궁화 고딕"/>
+                          <a:cs typeface="무궁화 고딕"/>
+                          <a:sym typeface="무궁화 고딕"/>
                         </a:rPr>
                         <a:t>모</a:t>
                       </a:r>
@@ -8403,10 +8399,10 @@
                           <a:solidFill>
                             <a:srgbClr val="000000"/>
                           </a:solidFill>
-                          <a:latin typeface="Jua"/>
-                          <a:ea typeface="Jua"/>
-                          <a:cs typeface="Jua"/>
-                          <a:sym typeface="Jua"/>
+                          <a:latin typeface="무궁화 고딕"/>
+                          <a:ea typeface="무궁화 고딕"/>
+                          <a:cs typeface="무궁화 고딕"/>
+                          <a:sym typeface="무궁화 고딕"/>
                         </a:rPr>
                         <a:t>시</a:t>
                       </a:r>
@@ -8468,10 +8464,10 @@
                           <a:solidFill>
                             <a:srgbClr val="000000"/>
                           </a:solidFill>
-                          <a:latin typeface="Jua"/>
-                          <a:ea typeface="Jua"/>
-                          <a:cs typeface="Jua"/>
-                          <a:sym typeface="Jua"/>
+                          <a:latin typeface="무궁화 고딕"/>
+                          <a:ea typeface="무궁화 고딕"/>
+                          <a:cs typeface="무궁화 고딕"/>
+                          <a:sym typeface="무궁화 고딕"/>
                         </a:rPr>
                         <a:t>여</a:t>
                       </a:r>
@@ -8535,10 +8531,10 @@
                           <a:solidFill>
                             <a:srgbClr val="000000"/>
                           </a:solidFill>
-                          <a:latin typeface="Jua"/>
-                          <a:ea typeface="Jua"/>
-                          <a:cs typeface="Jua"/>
-                          <a:sym typeface="Jua"/>
+                          <a:latin typeface="무궁화 고딕"/>
+                          <a:ea typeface="무궁화 고딕"/>
+                          <a:cs typeface="무궁화 고딕"/>
+                          <a:sym typeface="무궁화 고딕"/>
                         </a:rPr>
                         <a:t>다</a:t>
                       </a:r>
@@ -8600,10 +8596,10 @@
                           <a:solidFill>
                             <a:srgbClr val="000000"/>
                           </a:solidFill>
-                          <a:latin typeface="Jua"/>
-                          <a:ea typeface="Jua"/>
-                          <a:cs typeface="Jua"/>
-                          <a:sym typeface="Jua"/>
+                          <a:latin typeface="무궁화 고딕"/>
+                          <a:ea typeface="무궁화 고딕"/>
+                          <a:cs typeface="무궁화 고딕"/>
+                          <a:sym typeface="무궁화 고딕"/>
                         </a:rPr>
                         <a:t>원</a:t>
                       </a:r>
@@ -8665,10 +8661,10 @@
                           <a:solidFill>
                             <a:srgbClr val="000000"/>
                           </a:solidFill>
-                          <a:latin typeface="Jua"/>
-                          <a:ea typeface="Jua"/>
-                          <a:cs typeface="Jua"/>
-                          <a:sym typeface="Jua"/>
+                          <a:latin typeface="무궁화 고딕"/>
+                          <a:ea typeface="무궁화 고딕"/>
+                          <a:cs typeface="무궁화 고딕"/>
+                          <a:sym typeface="무궁화 고딕"/>
                         </a:rPr>
                         <a:t>으</a:t>
                       </a:r>
@@ -8732,10 +8728,10 @@
                           <a:solidFill>
                             <a:srgbClr val="000000"/>
                           </a:solidFill>
-                          <a:latin typeface="Jua"/>
-                          <a:ea typeface="Jua"/>
-                          <a:cs typeface="Jua"/>
-                          <a:sym typeface="Jua"/>
+                          <a:latin typeface="무궁화 고딕"/>
+                          <a:ea typeface="무궁화 고딕"/>
+                          <a:cs typeface="무궁화 고딕"/>
+                          <a:sym typeface="무궁화 고딕"/>
                         </a:rPr>
                         <a:t>로</a:t>
                       </a:r>
@@ -8797,10 +8793,10 @@
                           <a:solidFill>
                             <a:srgbClr val="000000"/>
                           </a:solidFill>
-                          <a:latin typeface="Jua"/>
-                          <a:ea typeface="Jua"/>
-                          <a:cs typeface="Jua"/>
-                          <a:sym typeface="Jua"/>
+                          <a:latin typeface="무궁화 고딕"/>
+                          <a:ea typeface="무궁화 고딕"/>
+                          <a:cs typeface="무궁화 고딕"/>
+                          <a:sym typeface="무궁화 고딕"/>
                         </a:rPr>
                         <a:t>앉</a:t>
                       </a:r>
@@ -8862,10 +8858,10 @@
                           <a:solidFill>
                             <a:srgbClr val="000000"/>
                           </a:solidFill>
-                          <a:latin typeface="Jua"/>
-                          <a:ea typeface="Jua"/>
-                          <a:cs typeface="Jua"/>
-                          <a:sym typeface="Jua"/>
+                          <a:latin typeface="무궁화 고딕"/>
+                          <a:ea typeface="무궁화 고딕"/>
+                          <a:cs typeface="무궁화 고딕"/>
+                          <a:sym typeface="무궁화 고딕"/>
                         </a:rPr>
                         <a:t>기</a:t>
                       </a:r>
@@ -9006,8 +9002,8 @@
         </p:nvSpPr>
         <p:spPr>
           <a:xfrm rot="0">
-            <a:off x="2717556" y="3895725"/>
-            <a:ext cx="12852888" cy="2200275"/>
+            <a:off x="2717556" y="4257675"/>
+            <a:ext cx="12852888" cy="1762125"/>
           </a:xfrm>
           <a:prstGeom prst="rect">
             <a:avLst/>
@@ -9021,18 +9017,18 @@
           <a:p>
             <a:pPr algn="ctr">
               <a:lnSpc>
-                <a:spcPts val="15000"/>
+                <a:spcPts val="13800"/>
               </a:lnSpc>
             </a:pPr>
             <a:r>
-              <a:rPr lang="en-US" sz="12500">
+              <a:rPr lang="en-US" sz="11500">
                 <a:solidFill>
                   <a:srgbClr val="000000"/>
                 </a:solidFill>
-                <a:latin typeface="Jua"/>
-                <a:ea typeface="Jua"/>
-                <a:cs typeface="Jua"/>
-                <a:sym typeface="Jua"/>
+                <a:latin typeface="무궁화 고딕"/>
+                <a:ea typeface="무궁화 고딕"/>
+                <a:cs typeface="무궁화 고딕"/>
+                <a:sym typeface="무궁화 고딕"/>
               </a:rPr>
               <a:t>다시 원으로 모여앉기</a:t>
             </a:r>
@@ -9109,10 +9105,10 @@
                           <a:solidFill>
                             <a:srgbClr val="000000"/>
                           </a:solidFill>
-                          <a:latin typeface="Jua"/>
-                          <a:ea typeface="Jua"/>
-                          <a:cs typeface="Jua"/>
-                          <a:sym typeface="Jua"/>
+                          <a:latin typeface="무궁화 고딕"/>
+                          <a:ea typeface="무궁화 고딕"/>
+                          <a:cs typeface="무궁화 고딕"/>
+                          <a:sym typeface="무궁화 고딕"/>
                         </a:rPr>
                         <a:t>이</a:t>
                       </a:r>
@@ -9174,10 +9170,10 @@
                           <a:solidFill>
                             <a:srgbClr val="000000"/>
                           </a:solidFill>
-                          <a:latin typeface="Jua"/>
-                          <a:ea typeface="Jua"/>
-                          <a:cs typeface="Jua"/>
-                          <a:sym typeface="Jua"/>
+                          <a:latin typeface="무궁화 고딕"/>
+                          <a:ea typeface="무궁화 고딕"/>
+                          <a:cs typeface="무궁화 고딕"/>
+                          <a:sym typeface="무궁화 고딕"/>
                         </a:rPr>
                         <a:t>하</a:t>
                       </a:r>
@@ -9239,10 +9235,10 @@
                           <a:solidFill>
                             <a:srgbClr val="000000"/>
                           </a:solidFill>
-                          <a:latin typeface="Jua"/>
-                          <a:ea typeface="Jua"/>
-                          <a:cs typeface="Jua"/>
-                          <a:sym typeface="Jua"/>
+                          <a:latin typeface="무궁화 고딕"/>
+                          <a:ea typeface="무궁화 고딕"/>
+                          <a:cs typeface="무궁화 고딕"/>
+                          <a:sym typeface="무궁화 고딕"/>
                         </a:rPr>
                         <a:t>브</a:t>
                       </a:r>
@@ -9306,10 +9302,10 @@
                           <a:solidFill>
                             <a:srgbClr val="000000"/>
                           </a:solidFill>
-                          <a:latin typeface="Jua"/>
-                          <a:ea typeface="Jua"/>
-                          <a:cs typeface="Jua"/>
-                          <a:sym typeface="Jua"/>
+                          <a:latin typeface="무궁화 고딕"/>
+                          <a:ea typeface="무궁화 고딕"/>
+                          <a:cs typeface="무궁화 고딕"/>
+                          <a:sym typeface="무궁화 고딕"/>
                         </a:rPr>
                         <a:t>사</a:t>
                       </a:r>
@@ -9371,10 +9367,10 @@
                           <a:solidFill>
                             <a:srgbClr val="000000"/>
                           </a:solidFill>
-                          <a:latin typeface="Jua"/>
-                          <a:ea typeface="Jua"/>
-                          <a:cs typeface="Jua"/>
-                          <a:sym typeface="Jua"/>
+                          <a:latin typeface="무궁화 고딕"/>
+                          <a:ea typeface="무궁화 고딕"/>
+                          <a:cs typeface="무궁화 고딕"/>
+                          <a:sym typeface="무궁화 고딕"/>
                         </a:rPr>
                         <a:t>파</a:t>
                       </a:r>
@@ -9436,10 +9432,10 @@
                           <a:solidFill>
                             <a:srgbClr val="000000"/>
                           </a:solidFill>
-                          <a:latin typeface="Jua"/>
-                          <a:ea typeface="Jua"/>
-                          <a:cs typeface="Jua"/>
-                          <a:sym typeface="Jua"/>
+                          <a:latin typeface="무궁화 고딕"/>
+                          <a:ea typeface="무궁화 고딕"/>
+                          <a:cs typeface="무궁화 고딕"/>
+                          <a:sym typeface="무궁화 고딕"/>
                         </a:rPr>
                         <a:t>옆</a:t>
                       </a:r>
@@ -9503,10 +9499,10 @@
                           <a:solidFill>
                             <a:srgbClr val="000000"/>
                           </a:solidFill>
-                          <a:latin typeface="Jua"/>
-                          <a:ea typeface="Jua"/>
-                          <a:cs typeface="Jua"/>
-                          <a:sym typeface="Jua"/>
+                          <a:latin typeface="무궁화 고딕"/>
+                          <a:ea typeface="무궁화 고딕"/>
+                          <a:cs typeface="무궁화 고딕"/>
+                          <a:sym typeface="무궁화 고딕"/>
                         </a:rPr>
                         <a:t>람</a:t>
                       </a:r>
@@ -9568,10 +9564,10 @@
                           <a:solidFill>
                             <a:srgbClr val="000000"/>
                           </a:solidFill>
-                          <a:latin typeface="Jua"/>
-                          <a:ea typeface="Jua"/>
-                          <a:cs typeface="Jua"/>
-                          <a:sym typeface="Jua"/>
+                          <a:latin typeface="무궁화 고딕"/>
+                          <a:ea typeface="무궁화 고딕"/>
+                          <a:cs typeface="무궁화 고딕"/>
+                          <a:sym typeface="무궁화 고딕"/>
                         </a:rPr>
                         <a:t>이</a:t>
                       </a:r>
@@ -9633,10 +9629,10 @@
                           <a:solidFill>
                             <a:srgbClr val="000000"/>
                           </a:solidFill>
-                          <a:latin typeface="Jua"/>
-                          <a:ea typeface="Jua"/>
-                          <a:cs typeface="Jua"/>
-                          <a:sym typeface="Jua"/>
+                          <a:latin typeface="무궁화 고딕"/>
+                          <a:ea typeface="무궁화 고딕"/>
+                          <a:cs typeface="무궁화 고딕"/>
+                          <a:sym typeface="무궁화 고딕"/>
                         </a:rPr>
                         <a:t>과</a:t>
                       </a:r>
@@ -9777,8 +9773,8 @@
         </p:nvSpPr>
         <p:spPr>
           <a:xfrm rot="0">
-            <a:off x="2717556" y="3895725"/>
-            <a:ext cx="12852888" cy="2200275"/>
+            <a:off x="2717556" y="4243387"/>
+            <a:ext cx="12852888" cy="1790700"/>
           </a:xfrm>
           <a:prstGeom prst="rect">
             <a:avLst/>
@@ -9792,18 +9788,18 @@
           <a:p>
             <a:pPr algn="ctr">
               <a:lnSpc>
-                <a:spcPts val="15000"/>
+                <a:spcPts val="14040"/>
               </a:lnSpc>
             </a:pPr>
             <a:r>
-              <a:rPr lang="en-US" sz="12500">
+              <a:rPr lang="en-US" sz="11700">
                 <a:solidFill>
                   <a:srgbClr val="000000"/>
                 </a:solidFill>
-                <a:latin typeface="Jua"/>
-                <a:ea typeface="Jua"/>
-                <a:cs typeface="Jua"/>
-                <a:sym typeface="Jua"/>
+                <a:latin typeface="무궁화 고딕"/>
+                <a:ea typeface="무궁화 고딕"/>
+                <a:cs typeface="무궁화 고딕"/>
+                <a:sym typeface="무궁화 고딕"/>
               </a:rPr>
               <a:t>옆사람과 하이파이브</a:t>
             </a:r>
@@ -9880,10 +9876,10 @@
                           <a:solidFill>
                             <a:srgbClr val="000000"/>
                           </a:solidFill>
-                          <a:latin typeface="Jua"/>
-                          <a:ea typeface="Jua"/>
-                          <a:cs typeface="Jua"/>
-                          <a:sym typeface="Jua"/>
+                          <a:latin typeface="무궁화 고딕"/>
+                          <a:ea typeface="무궁화 고딕"/>
+                          <a:cs typeface="무궁화 고딕"/>
+                          <a:sym typeface="무궁화 고딕"/>
                         </a:rPr>
                         <a:t>부</a:t>
                       </a:r>
@@ -9945,10 +9941,10 @@
                           <a:solidFill>
                             <a:srgbClr val="000000"/>
                           </a:solidFill>
-                          <a:latin typeface="Jua"/>
-                          <a:ea typeface="Jua"/>
-                          <a:cs typeface="Jua"/>
-                          <a:sym typeface="Jua"/>
+                          <a:latin typeface="무궁화 고딕"/>
+                          <a:ea typeface="무궁화 고딕"/>
+                          <a:cs typeface="무궁화 고딕"/>
+                          <a:sym typeface="무궁화 고딕"/>
                         </a:rPr>
                         <a:t>세</a:t>
                       </a:r>
@@ -10010,10 +10006,10 @@
                           <a:solidFill>
                             <a:srgbClr val="000000"/>
                           </a:solidFill>
-                          <a:latin typeface="Jua"/>
-                          <a:ea typeface="Jua"/>
-                          <a:cs typeface="Jua"/>
-                          <a:sym typeface="Jua"/>
+                          <a:latin typeface="무궁화 고딕"/>
+                          <a:ea typeface="무궁화 고딕"/>
+                          <a:cs typeface="무궁화 고딕"/>
+                          <a:sym typeface="무궁화 고딕"/>
                         </a:rPr>
                         <a:t>나</a:t>
                       </a:r>
@@ -10077,10 +10073,10 @@
                           <a:solidFill>
                             <a:srgbClr val="000000"/>
                           </a:solidFill>
-                          <a:latin typeface="Jua"/>
-                          <a:ea typeface="Jua"/>
-                          <a:cs typeface="Jua"/>
-                          <a:sym typeface="Jua"/>
+                          <a:latin typeface="무궁화 고딕"/>
+                          <a:ea typeface="무궁화 고딕"/>
+                          <a:cs typeface="무궁화 고딕"/>
+                          <a:sym typeface="무궁화 고딕"/>
                         </a:rPr>
                         <a:t>기</a:t>
                       </a:r>
@@ -10142,10 +10138,10 @@
                           <a:solidFill>
                             <a:srgbClr val="000000"/>
                           </a:solidFill>
-                          <a:latin typeface="Jua"/>
-                          <a:ea typeface="Jua"/>
-                          <a:cs typeface="Jua"/>
-                          <a:sym typeface="Jua"/>
+                          <a:latin typeface="무궁화 고딕"/>
+                          <a:ea typeface="무궁화 고딕"/>
+                          <a:cs typeface="무궁화 고딕"/>
+                          <a:sym typeface="무궁화 고딕"/>
                         </a:rPr>
                         <a:t>만</a:t>
                       </a:r>
@@ -10207,10 +10203,10 @@
                           <a:solidFill>
                             <a:srgbClr val="000000"/>
                           </a:solidFill>
-                          <a:latin typeface="Jua"/>
-                          <a:ea typeface="Jua"/>
-                          <a:cs typeface="Jua"/>
-                          <a:sym typeface="Jua"/>
+                          <a:latin typeface="무궁화 고딕"/>
+                          <a:ea typeface="무궁화 고딕"/>
+                          <a:cs typeface="무궁화 고딕"/>
+                          <a:sym typeface="무궁화 고딕"/>
                         </a:rPr>
                         <a:t>일</a:t>
                       </a:r>
@@ -10274,10 +10270,10 @@
                           <a:solidFill>
                             <a:srgbClr val="000000"/>
                           </a:solidFill>
-                          <a:latin typeface="Jua"/>
-                          <a:ea typeface="Jua"/>
-                          <a:cs typeface="Jua"/>
-                          <a:sym typeface="Jua"/>
+                          <a:latin typeface="무궁화 고딕"/>
+                          <a:ea typeface="무궁화 고딕"/>
+                          <a:cs typeface="무궁화 고딕"/>
+                          <a:sym typeface="무궁화 고딕"/>
                         </a:rPr>
                         <a:t>르</a:t>
                       </a:r>
@@ -10339,10 +10335,10 @@
                           <a:solidFill>
                             <a:srgbClr val="000000"/>
                           </a:solidFill>
-                          <a:latin typeface="Jua"/>
-                          <a:ea typeface="Jua"/>
-                          <a:cs typeface="Jua"/>
-                          <a:sym typeface="Jua"/>
+                          <a:latin typeface="무궁화 고딕"/>
+                          <a:ea typeface="무궁화 고딕"/>
+                          <a:cs typeface="무궁화 고딕"/>
+                          <a:sym typeface="무궁화 고딕"/>
                         </a:rPr>
                         <a:t>서</a:t>
                       </a:r>
@@ -10404,10 +10400,10 @@
                           <a:solidFill>
                             <a:srgbClr val="000000"/>
                           </a:solidFill>
-                          <a:latin typeface="Jua"/>
-                          <a:ea typeface="Jua"/>
-                          <a:cs typeface="Jua"/>
-                          <a:sym typeface="Jua"/>
+                          <a:latin typeface="무궁화 고딕"/>
+                          <a:ea typeface="무궁화 고딕"/>
+                          <a:cs typeface="무궁화 고딕"/>
+                          <a:sym typeface="무궁화 고딕"/>
                         </a:rPr>
                         <a:t>어</a:t>
                       </a:r>
@@ -10548,8 +10544,8 @@
         </p:nvSpPr>
         <p:spPr>
           <a:xfrm rot="0">
-            <a:off x="2717556" y="3895725"/>
-            <a:ext cx="12852888" cy="2200275"/>
+            <a:off x="2717556" y="4238625"/>
+            <a:ext cx="12852888" cy="1800225"/>
           </a:xfrm>
           <a:prstGeom prst="rect">
             <a:avLst/>
@@ -10563,18 +10559,18 @@
           <a:p>
             <a:pPr algn="ctr">
               <a:lnSpc>
-                <a:spcPts val="15000"/>
+                <a:spcPts val="14160"/>
               </a:lnSpc>
             </a:pPr>
             <a:r>
-              <a:rPr lang="en-US" sz="12500">
+              <a:rPr lang="en-US" sz="11800">
                 <a:solidFill>
                   <a:srgbClr val="000000"/>
                 </a:solidFill>
-                <a:latin typeface="Jua"/>
-                <a:ea typeface="Jua"/>
-                <a:cs typeface="Jua"/>
-                <a:sym typeface="Jua"/>
+                <a:latin typeface="무궁화 고딕"/>
+                <a:ea typeface="무궁화 고딕"/>
+                <a:cs typeface="무궁화 고딕"/>
+                <a:sym typeface="무궁화 고딕"/>
               </a:rPr>
               <a:t>일어나서 만세 부르기</a:t>
             </a:r>
@@ -10651,10 +10647,10 @@
                           <a:solidFill>
                             <a:srgbClr val="000000"/>
                           </a:solidFill>
-                          <a:latin typeface="Jua"/>
-                          <a:ea typeface="Jua"/>
-                          <a:cs typeface="Jua"/>
-                          <a:sym typeface="Jua"/>
+                          <a:latin typeface="무궁화 고딕"/>
+                          <a:ea typeface="무궁화 고딕"/>
+                          <a:cs typeface="무궁화 고딕"/>
+                          <a:sym typeface="무궁화 고딕"/>
                         </a:rPr>
                         <a:t>제</a:t>
                       </a:r>
@@ -10716,10 +10712,10 @@
                           <a:solidFill>
                             <a:srgbClr val="000000"/>
                           </a:solidFill>
-                          <a:latin typeface="Jua"/>
-                          <a:ea typeface="Jua"/>
-                          <a:cs typeface="Jua"/>
-                          <a:sym typeface="Jua"/>
+                          <a:latin typeface="무궁화 고딕"/>
+                          <a:ea typeface="무궁화 고딕"/>
+                          <a:cs typeface="무궁화 고딕"/>
+                          <a:sym typeface="무궁화 고딕"/>
                         </a:rPr>
                         <a:t>돌</a:t>
                       </a:r>
@@ -10781,10 +10777,10 @@
                           <a:solidFill>
                             <a:srgbClr val="000000"/>
                           </a:solidFill>
-                          <a:latin typeface="Jua"/>
-                          <a:ea typeface="Jua"/>
-                          <a:cs typeface="Jua"/>
-                          <a:sym typeface="Jua"/>
+                          <a:latin typeface="무궁화 고딕"/>
+                          <a:ea typeface="무궁화 고딕"/>
+                          <a:cs typeface="무궁화 고딕"/>
+                          <a:sym typeface="무궁화 고딕"/>
                         </a:rPr>
                         <a:t>양</a:t>
                       </a:r>
@@ -10848,10 +10844,10 @@
                           <a:solidFill>
                             <a:srgbClr val="000000"/>
                           </a:solidFill>
-                          <a:latin typeface="Jua"/>
-                          <a:ea typeface="Jua"/>
-                          <a:cs typeface="Jua"/>
-                          <a:sym typeface="Jua"/>
+                          <a:latin typeface="무궁화 고딕"/>
+                          <a:ea typeface="무궁화 고딕"/>
+                          <a:cs typeface="무궁화 고딕"/>
+                          <a:sym typeface="무궁화 고딕"/>
                         </a:rPr>
                         <a:t>기</a:t>
                       </a:r>
@@ -10913,10 +10909,10 @@
                           <a:solidFill>
                             <a:srgbClr val="000000"/>
                           </a:solidFill>
-                          <a:latin typeface="Jua"/>
-                          <a:ea typeface="Jua"/>
-                          <a:cs typeface="Jua"/>
-                          <a:sym typeface="Jua"/>
+                          <a:latin typeface="무궁화 고딕"/>
+                          <a:ea typeface="무궁화 고딕"/>
+                          <a:cs typeface="무궁화 고딕"/>
+                          <a:sym typeface="무궁화 고딕"/>
                         </a:rPr>
                         <a:t>손</a:t>
                       </a:r>
@@ -10978,10 +10974,10 @@
                           <a:solidFill>
                             <a:srgbClr val="000000"/>
                           </a:solidFill>
-                          <a:latin typeface="Jua"/>
-                          <a:ea typeface="Jua"/>
-                          <a:cs typeface="Jua"/>
-                          <a:sym typeface="Jua"/>
+                          <a:latin typeface="무궁화 고딕"/>
+                          <a:ea typeface="무궁화 고딕"/>
+                          <a:cs typeface="무궁화 고딕"/>
+                          <a:sym typeface="무궁화 고딕"/>
                         </a:rPr>
                         <a:t>리</a:t>
                       </a:r>
@@ -11045,10 +11041,10 @@
                           <a:solidFill>
                             <a:srgbClr val="000000"/>
                           </a:solidFill>
-                          <a:latin typeface="Jua"/>
-                          <a:ea typeface="Jua"/>
-                          <a:cs typeface="Jua"/>
-                          <a:sym typeface="Jua"/>
+                          <a:latin typeface="무궁화 고딕"/>
+                          <a:ea typeface="무궁화 고딕"/>
+                          <a:cs typeface="무궁화 고딕"/>
+                          <a:sym typeface="무궁화 고딕"/>
                         </a:rPr>
                         <a:t>고</a:t>
                       </a:r>
@@ -11110,10 +11106,10 @@
                           <a:solidFill>
                             <a:srgbClr val="000000"/>
                           </a:solidFill>
-                          <a:latin typeface="Jua"/>
-                          <a:ea typeface="Jua"/>
-                          <a:cs typeface="Jua"/>
-                          <a:sym typeface="Jua"/>
+                          <a:latin typeface="무궁화 고딕"/>
+                          <a:ea typeface="무궁화 고딕"/>
+                          <a:cs typeface="무궁화 고딕"/>
+                          <a:sym typeface="무궁화 고딕"/>
                         </a:rPr>
                         <a:t>자</a:t>
                       </a:r>
@@ -11175,10 +11171,10 @@
                           <a:solidFill>
                             <a:srgbClr val="000000"/>
                           </a:solidFill>
-                          <a:latin typeface="Jua"/>
-                          <a:ea typeface="Jua"/>
-                          <a:cs typeface="Jua"/>
-                          <a:sym typeface="Jua"/>
+                          <a:latin typeface="무궁화 고딕"/>
+                          <a:ea typeface="무궁화 고딕"/>
+                          <a:cs typeface="무궁화 고딕"/>
+                          <a:sym typeface="무궁화 고딕"/>
                         </a:rPr>
                         <a:t>들</a:t>
                       </a:r>
@@ -11269,8 +11265,8 @@
         </p:nvSpPr>
         <p:spPr>
           <a:xfrm rot="0">
-            <a:off x="3238925" y="4092795"/>
-            <a:ext cx="11810151" cy="2200275"/>
+            <a:off x="3238925" y="4378545"/>
+            <a:ext cx="11810151" cy="1914525"/>
           </a:xfrm>
           <a:prstGeom prst="rect">
             <a:avLst/>
@@ -11292,10 +11288,10 @@
                 <a:solidFill>
                   <a:srgbClr val="000000"/>
                 </a:solidFill>
-                <a:latin typeface="Jua"/>
-                <a:ea typeface="Jua"/>
-                <a:cs typeface="Jua"/>
-                <a:sym typeface="Jua"/>
+                <a:latin typeface="무궁화 고딕"/>
+                <a:ea typeface="무궁화 고딕"/>
+                <a:cs typeface="무궁화 고딕"/>
+                <a:sym typeface="무궁화 고딕"/>
               </a:rPr>
               <a:t>팀을 나눠주세요!</a:t>
             </a:r>
@@ -11442,8 +11438,8 @@
         </p:nvSpPr>
         <p:spPr>
           <a:xfrm rot="0">
-            <a:off x="2717556" y="3895725"/>
-            <a:ext cx="12852888" cy="2200275"/>
+            <a:off x="2717556" y="4267200"/>
+            <a:ext cx="12852888" cy="1743075"/>
           </a:xfrm>
           <a:prstGeom prst="rect">
             <a:avLst/>
@@ -11457,18 +11453,18 @@
           <a:p>
             <a:pPr algn="ctr">
               <a:lnSpc>
-                <a:spcPts val="15000"/>
+                <a:spcPts val="13680"/>
               </a:lnSpc>
             </a:pPr>
             <a:r>
-              <a:rPr lang="en-US" sz="12500">
+              <a:rPr lang="en-US" sz="11400">
                 <a:solidFill>
                   <a:srgbClr val="000000"/>
                 </a:solidFill>
-                <a:latin typeface="Jua"/>
-                <a:ea typeface="Jua"/>
-                <a:cs typeface="Jua"/>
-                <a:sym typeface="Jua"/>
+                <a:latin typeface="무궁화 고딕"/>
+                <a:ea typeface="무궁화 고딕"/>
+                <a:cs typeface="무궁화 고딕"/>
+                <a:sym typeface="무궁화 고딕"/>
               </a:rPr>
               <a:t>양손 들고 제자리 돌기</a:t>
             </a:r>
@@ -11545,10 +11541,10 @@
                           <a:solidFill>
                             <a:srgbClr val="000000"/>
                           </a:solidFill>
-                          <a:latin typeface="Jua"/>
-                          <a:ea typeface="Jua"/>
-                          <a:cs typeface="Jua"/>
-                          <a:sym typeface="Jua"/>
+                          <a:latin typeface="무궁화 고딕"/>
+                          <a:ea typeface="무궁화 고딕"/>
+                          <a:cs typeface="무궁화 고딕"/>
+                          <a:sym typeface="무궁화 고딕"/>
                         </a:rPr>
                         <a:t>기</a:t>
                       </a:r>
@@ -11610,10 +11606,10 @@
                           <a:solidFill>
                             <a:srgbClr val="000000"/>
                           </a:solidFill>
-                          <a:latin typeface="Jua"/>
-                          <a:ea typeface="Jua"/>
-                          <a:cs typeface="Jua"/>
-                          <a:sym typeface="Jua"/>
+                          <a:latin typeface="무궁화 고딕"/>
+                          <a:ea typeface="무궁화 고딕"/>
+                          <a:cs typeface="무궁화 고딕"/>
+                          <a:sym typeface="무궁화 고딕"/>
                         </a:rPr>
                         <a:t>모</a:t>
                       </a:r>
@@ -11675,10 +11671,10 @@
                           <a:solidFill>
                             <a:srgbClr val="000000"/>
                           </a:solidFill>
-                          <a:latin typeface="Jua"/>
-                          <a:ea typeface="Jua"/>
-                          <a:cs typeface="Jua"/>
-                          <a:sym typeface="Jua"/>
+                          <a:latin typeface="무궁화 고딕"/>
+                          <a:ea typeface="무궁화 고딕"/>
+                          <a:cs typeface="무궁화 고딕"/>
+                          <a:sym typeface="무궁화 고딕"/>
                         </a:rPr>
                         <a:t>하</a:t>
                       </a:r>
@@ -11742,10 +11738,10 @@
                           <a:solidFill>
                             <a:srgbClr val="000000"/>
                           </a:solidFill>
-                          <a:latin typeface="Jua"/>
-                          <a:ea typeface="Jua"/>
-                          <a:cs typeface="Jua"/>
-                          <a:sym typeface="Jua"/>
+                          <a:latin typeface="무궁화 고딕"/>
+                          <a:ea typeface="무궁화 고딕"/>
+                          <a:cs typeface="무궁화 고딕"/>
+                          <a:sym typeface="무궁화 고딕"/>
                         </a:rPr>
                         <a:t>서</a:t>
                       </a:r>
@@ -11807,10 +11803,10 @@
                           <a:solidFill>
                             <a:srgbClr val="000000"/>
                           </a:solidFill>
-                          <a:latin typeface="Jua"/>
-                          <a:ea typeface="Jua"/>
-                          <a:cs typeface="Jua"/>
-                          <a:sym typeface="Jua"/>
+                          <a:latin typeface="무궁화 고딕"/>
+                          <a:ea typeface="무궁화 고딕"/>
+                          <a:cs typeface="무궁화 고딕"/>
+                          <a:sym typeface="무궁화 고딕"/>
                         </a:rPr>
                         <a:t>두</a:t>
                       </a:r>
@@ -11872,10 +11868,10 @@
                           <a:solidFill>
                             <a:srgbClr val="000000"/>
                           </a:solidFill>
-                          <a:latin typeface="Jua"/>
-                          <a:ea typeface="Jua"/>
-                          <a:cs typeface="Jua"/>
-                          <a:sym typeface="Jua"/>
+                          <a:latin typeface="무궁화 고딕"/>
+                          <a:ea typeface="무궁화 고딕"/>
+                          <a:cs typeface="무궁화 고딕"/>
+                          <a:sym typeface="무궁화 고딕"/>
                         </a:rPr>
                         <a:t>도</a:t>
                       </a:r>
@@ -11939,10 +11935,10 @@
                           <a:solidFill>
                             <a:srgbClr val="000000"/>
                           </a:solidFill>
-                          <a:latin typeface="Jua"/>
-                          <a:ea typeface="Jua"/>
-                          <a:cs typeface="Jua"/>
-                          <a:sym typeface="Jua"/>
+                          <a:latin typeface="무궁화 고딕"/>
+                          <a:ea typeface="무궁화 고딕"/>
+                          <a:cs typeface="무궁화 고딕"/>
+                          <a:sym typeface="무궁화 고딕"/>
                         </a:rPr>
                         <a:t>아</a:t>
                       </a:r>
@@ -12004,10 +12000,10 @@
                           <a:solidFill>
                             <a:srgbClr val="000000"/>
                           </a:solidFill>
-                          <a:latin typeface="Jua"/>
-                          <a:ea typeface="Jua"/>
-                          <a:cs typeface="Jua"/>
-                          <a:sym typeface="Jua"/>
+                          <a:latin typeface="무궁화 고딕"/>
+                          <a:ea typeface="무궁화 고딕"/>
+                          <a:cs typeface="무궁화 고딕"/>
+                          <a:sym typeface="무궁화 고딕"/>
                         </a:rPr>
                         <a:t>기</a:t>
                       </a:r>
@@ -12069,10 +12065,10 @@
                           <a:solidFill>
                             <a:srgbClr val="000000"/>
                           </a:solidFill>
-                          <a:latin typeface="Jua"/>
-                          <a:ea typeface="Jua"/>
-                          <a:cs typeface="Jua"/>
-                          <a:sym typeface="Jua"/>
+                          <a:latin typeface="무궁화 고딕"/>
+                          <a:ea typeface="무궁화 고딕"/>
+                          <a:cs typeface="무궁화 고딕"/>
+                          <a:sym typeface="무궁화 고딕"/>
                         </a:rPr>
                         <a:t>손</a:t>
                       </a:r>
@@ -12213,8 +12209,8 @@
         </p:nvSpPr>
         <p:spPr>
           <a:xfrm rot="0">
-            <a:off x="2717556" y="3895725"/>
-            <a:ext cx="12852888" cy="2200275"/>
+            <a:off x="2717556" y="4252913"/>
+            <a:ext cx="12852888" cy="1771650"/>
           </a:xfrm>
           <a:prstGeom prst="rect">
             <a:avLst/>
@@ -12228,18 +12224,18 @@
           <a:p>
             <a:pPr algn="ctr">
               <a:lnSpc>
-                <a:spcPts val="15000"/>
+                <a:spcPts val="13920"/>
               </a:lnSpc>
             </a:pPr>
             <a:r>
-              <a:rPr lang="en-US" sz="12500">
+              <a:rPr lang="en-US" sz="11600">
                 <a:solidFill>
                   <a:srgbClr val="000000"/>
                 </a:solidFill>
-                <a:latin typeface="Jua"/>
-                <a:ea typeface="Jua"/>
-                <a:cs typeface="Jua"/>
-                <a:sym typeface="Jua"/>
+                <a:latin typeface="무궁화 고딕"/>
+                <a:ea typeface="무궁화 고딕"/>
+                <a:cs typeface="무궁화 고딕"/>
+                <a:sym typeface="무궁화 고딕"/>
               </a:rPr>
               <a:t>두손 모아서 기도하기</a:t>
             </a:r>
@@ -12317,10 +12313,10 @@
                           <a:solidFill>
                             <a:srgbClr val="000000"/>
                           </a:solidFill>
-                          <a:latin typeface="Jua"/>
-                          <a:ea typeface="Jua"/>
-                          <a:cs typeface="Jua"/>
-                          <a:sym typeface="Jua"/>
+                          <a:latin typeface="무궁화 고딕"/>
+                          <a:ea typeface="무궁화 고딕"/>
+                          <a:cs typeface="무궁화 고딕"/>
+                          <a:sym typeface="무궁화 고딕"/>
                         </a:rPr>
                         <a:t>말</a:t>
                       </a:r>
@@ -12382,10 +12378,10 @@
                           <a:solidFill>
                             <a:srgbClr val="000000"/>
                           </a:solidFill>
-                          <a:latin typeface="Jua"/>
-                          <a:ea typeface="Jua"/>
-                          <a:cs typeface="Jua"/>
-                          <a:sym typeface="Jua"/>
+                          <a:latin typeface="무궁화 고딕"/>
+                          <a:ea typeface="무궁화 고딕"/>
+                          <a:cs typeface="무궁화 고딕"/>
+                          <a:sym typeface="무궁화 고딕"/>
                         </a:rPr>
                         <a:t>고</a:t>
                       </a:r>
@@ -12447,10 +12443,10 @@
                           <a:solidFill>
                             <a:srgbClr val="000000"/>
                           </a:solidFill>
-                          <a:latin typeface="Jua"/>
-                          <a:ea typeface="Jua"/>
-                          <a:cs typeface="Jua"/>
-                          <a:sym typeface="Jua"/>
+                          <a:latin typeface="무궁화 고딕"/>
+                          <a:ea typeface="무궁화 고딕"/>
+                          <a:cs typeface="무궁화 고딕"/>
+                          <a:sym typeface="무궁화 고딕"/>
                         </a:rPr>
                         <a:t>기</a:t>
                       </a:r>
@@ -12512,10 +12508,10 @@
                           <a:solidFill>
                             <a:srgbClr val="000000"/>
                           </a:solidFill>
-                          <a:latin typeface="Jua"/>
-                          <a:ea typeface="Jua"/>
-                          <a:cs typeface="Jua"/>
-                          <a:sym typeface="Jua"/>
+                          <a:latin typeface="무궁화 고딕"/>
+                          <a:ea typeface="무궁화 고딕"/>
+                          <a:cs typeface="무궁화 고딕"/>
+                          <a:sym typeface="무궁화 고딕"/>
                         </a:rPr>
                         <a:t>람</a:t>
                       </a:r>
@@ -12579,10 +12575,10 @@
                           <a:solidFill>
                             <a:srgbClr val="000000"/>
                           </a:solidFill>
-                          <a:latin typeface="Jua"/>
-                          <a:ea typeface="Jua"/>
-                          <a:cs typeface="Jua"/>
-                          <a:sym typeface="Jua"/>
+                          <a:latin typeface="무궁화 고딕"/>
+                          <a:ea typeface="무궁화 고딕"/>
+                          <a:cs typeface="무궁화 고딕"/>
+                          <a:sym typeface="무궁화 고딕"/>
                         </a:rPr>
                         <a:t>다</a:t>
                       </a:r>
@@ -12644,10 +12640,10 @@
                           <a:solidFill>
                             <a:srgbClr val="000000"/>
                           </a:solidFill>
-                          <a:latin typeface="Jua"/>
-                          <a:ea typeface="Jua"/>
-                          <a:cs typeface="Jua"/>
-                          <a:sym typeface="Jua"/>
+                          <a:latin typeface="무궁화 고딕"/>
+                          <a:ea typeface="무궁화 고딕"/>
+                          <a:cs typeface="무궁화 고딕"/>
+                          <a:sym typeface="무궁화 고딕"/>
                         </a:rPr>
                         <a:t>사</a:t>
                       </a:r>
@@ -12709,10 +12705,10 @@
                           <a:solidFill>
                             <a:srgbClr val="000000"/>
                           </a:solidFill>
-                          <a:latin typeface="Jua"/>
-                          <a:ea typeface="Jua"/>
-                          <a:cs typeface="Jua"/>
-                          <a:sym typeface="Jua"/>
+                          <a:latin typeface="무궁화 고딕"/>
+                          <a:ea typeface="무궁화 고딕"/>
+                          <a:cs typeface="무궁화 고딕"/>
+                          <a:sym typeface="무궁화 고딕"/>
                         </a:rPr>
                         <a:t>옆</a:t>
                       </a:r>
@@ -12774,10 +12770,10 @@
                           <a:solidFill>
                             <a:srgbClr val="000000"/>
                           </a:solidFill>
-                          <a:latin typeface="Jua"/>
-                          <a:ea typeface="Jua"/>
-                          <a:cs typeface="Jua"/>
-                          <a:sym typeface="Jua"/>
+                          <a:latin typeface="무궁화 고딕"/>
+                          <a:ea typeface="무궁화 고딕"/>
+                          <a:cs typeface="무궁화 고딕"/>
+                          <a:sym typeface="무궁화 고딕"/>
                         </a:rPr>
                         <a:t>예</a:t>
                       </a:r>
@@ -12841,10 +12837,10 @@
                           <a:solidFill>
                             <a:srgbClr val="000000"/>
                           </a:solidFill>
-                          <a:latin typeface="Jua"/>
-                          <a:ea typeface="Jua"/>
-                          <a:cs typeface="Jua"/>
-                          <a:sym typeface="Jua"/>
+                          <a:latin typeface="무궁화 고딕"/>
+                          <a:ea typeface="무궁화 고딕"/>
+                          <a:cs typeface="무궁화 고딕"/>
+                          <a:sym typeface="무궁화 고딕"/>
                         </a:rPr>
                         <a:t>에</a:t>
                       </a:r>
@@ -12906,10 +12902,10 @@
                           <a:solidFill>
                             <a:srgbClr val="000000"/>
                           </a:solidFill>
-                          <a:latin typeface="Jua"/>
-                          <a:ea typeface="Jua"/>
-                          <a:cs typeface="Jua"/>
-                          <a:sym typeface="Jua"/>
+                          <a:latin typeface="무궁화 고딕"/>
+                          <a:ea typeface="무궁화 고딕"/>
+                          <a:cs typeface="무궁화 고딕"/>
+                          <a:sym typeface="무궁화 고딕"/>
                         </a:rPr>
                         <a:t>하</a:t>
                       </a:r>
@@ -12971,10 +12967,10 @@
                           <a:solidFill>
                             <a:srgbClr val="000000"/>
                           </a:solidFill>
-                          <a:latin typeface="Jua"/>
-                          <a:ea typeface="Jua"/>
-                          <a:cs typeface="Jua"/>
-                          <a:sym typeface="Jua"/>
+                          <a:latin typeface="무궁화 고딕"/>
+                          <a:ea typeface="무궁화 고딕"/>
+                          <a:cs typeface="무궁화 고딕"/>
+                          <a:sym typeface="무궁화 고딕"/>
                         </a:rPr>
                         <a:t>게</a:t>
                       </a:r>
@@ -13036,10 +13032,10 @@
                           <a:solidFill>
                             <a:srgbClr val="000000"/>
                           </a:solidFill>
-                          <a:latin typeface="Jua"/>
-                          <a:ea typeface="Jua"/>
-                          <a:cs typeface="Jua"/>
-                          <a:sym typeface="Jua"/>
+                          <a:latin typeface="무궁화 고딕"/>
+                          <a:ea typeface="무궁화 고딕"/>
+                          <a:cs typeface="무궁화 고딕"/>
+                          <a:sym typeface="무궁화 고딕"/>
                         </a:rPr>
                         <a:t>쁘</a:t>
                       </a:r>
@@ -13180,8 +13176,8 @@
         </p:nvSpPr>
         <p:spPr>
           <a:xfrm rot="0">
-            <a:off x="461635" y="3895725"/>
-            <a:ext cx="17364730" cy="2200275"/>
+            <a:off x="461635" y="4252913"/>
+            <a:ext cx="17364730" cy="1771650"/>
           </a:xfrm>
           <a:prstGeom prst="rect">
             <a:avLst/>
@@ -13195,18 +13191,18 @@
           <a:p>
             <a:pPr algn="ctr">
               <a:lnSpc>
-                <a:spcPts val="15000"/>
+                <a:spcPts val="13920"/>
               </a:lnSpc>
             </a:pPr>
             <a:r>
-              <a:rPr lang="en-US" sz="12500">
+              <a:rPr lang="en-US" sz="11600">
                 <a:solidFill>
                   <a:srgbClr val="000000"/>
                 </a:solidFill>
-                <a:latin typeface="Jua"/>
-                <a:ea typeface="Jua"/>
-                <a:cs typeface="Jua"/>
-                <a:sym typeface="Jua"/>
+                <a:latin typeface="무궁화 고딕"/>
+                <a:ea typeface="무궁화 고딕"/>
+                <a:cs typeface="무궁화 고딕"/>
+                <a:sym typeface="무궁화 고딕"/>
               </a:rPr>
               <a:t>옆 사람에게 예쁘다고 말하기</a:t>
             </a:r>
@@ -13284,10 +13280,10 @@
                           <a:solidFill>
                             <a:srgbClr val="000000"/>
                           </a:solidFill>
-                          <a:latin typeface="Jua"/>
-                          <a:ea typeface="Jua"/>
-                          <a:cs typeface="Jua"/>
-                          <a:sym typeface="Jua"/>
+                          <a:latin typeface="무궁화 고딕"/>
+                          <a:ea typeface="무궁화 고딕"/>
+                          <a:cs typeface="무궁화 고딕"/>
+                          <a:sym typeface="무궁화 고딕"/>
                         </a:rPr>
                         <a:t>세</a:t>
                       </a:r>
@@ -13349,10 +13345,10 @@
                           <a:solidFill>
                             <a:srgbClr val="000000"/>
                           </a:solidFill>
-                          <a:latin typeface="Jua"/>
-                          <a:ea typeface="Jua"/>
-                          <a:cs typeface="Jua"/>
-                          <a:sym typeface="Jua"/>
+                          <a:latin typeface="무궁화 고딕"/>
+                          <a:ea typeface="무궁화 고딕"/>
+                          <a:cs typeface="무궁화 고딕"/>
+                          <a:sym typeface="무궁화 고딕"/>
                         </a:rPr>
                         <a:t>돌</a:t>
                       </a:r>
@@ -13414,10 +13410,10 @@
                           <a:solidFill>
                             <a:srgbClr val="000000"/>
                           </a:solidFill>
-                          <a:latin typeface="Jua"/>
-                          <a:ea typeface="Jua"/>
-                          <a:cs typeface="Jua"/>
-                          <a:sym typeface="Jua"/>
+                          <a:latin typeface="무궁화 고딕"/>
+                          <a:ea typeface="무궁화 고딕"/>
+                          <a:cs typeface="무궁화 고딕"/>
+                          <a:sym typeface="무궁화 고딕"/>
                         </a:rPr>
                         <a:t>나</a:t>
                       </a:r>
@@ -13479,10 +13475,10 @@
                           <a:solidFill>
                             <a:srgbClr val="000000"/>
                           </a:solidFill>
-                          <a:latin typeface="Jua"/>
-                          <a:ea typeface="Jua"/>
-                          <a:cs typeface="Jua"/>
-                          <a:sym typeface="Jua"/>
+                          <a:latin typeface="무궁화 고딕"/>
+                          <a:ea typeface="무궁화 고딕"/>
+                          <a:cs typeface="무궁화 고딕"/>
+                          <a:sym typeface="무궁화 고딕"/>
                         </a:rPr>
                         <a:t>퀴</a:t>
                       </a:r>
@@ -13546,10 +13542,10 @@
                           <a:solidFill>
                             <a:srgbClr val="000000"/>
                           </a:solidFill>
-                          <a:latin typeface="Jua"/>
-                          <a:ea typeface="Jua"/>
-                          <a:cs typeface="Jua"/>
-                          <a:sym typeface="Jua"/>
+                          <a:latin typeface="무궁화 고딕"/>
+                          <a:ea typeface="무궁화 고딕"/>
+                          <a:cs typeface="무궁화 고딕"/>
+                          <a:sym typeface="무궁화 고딕"/>
                         </a:rPr>
                         <a:t>자</a:t>
                       </a:r>
@@ -13611,10 +13607,10 @@
                           <a:solidFill>
                             <a:srgbClr val="000000"/>
                           </a:solidFill>
-                          <a:latin typeface="Jua"/>
-                          <a:ea typeface="Jua"/>
-                          <a:cs typeface="Jua"/>
-                          <a:sym typeface="Jua"/>
+                          <a:latin typeface="무궁화 고딕"/>
+                          <a:ea typeface="무궁화 고딕"/>
+                          <a:cs typeface="무궁화 고딕"/>
+                          <a:sym typeface="무궁화 고딕"/>
                         </a:rPr>
                         <a:t>기</a:t>
                       </a:r>
@@ -13676,10 +13672,10 @@
                           <a:solidFill>
                             <a:srgbClr val="000000"/>
                           </a:solidFill>
-                          <a:latin typeface="Jua"/>
-                          <a:ea typeface="Jua"/>
-                          <a:cs typeface="Jua"/>
-                          <a:sym typeface="Jua"/>
+                          <a:latin typeface="무궁화 고딕"/>
+                          <a:ea typeface="무궁화 고딕"/>
+                          <a:cs typeface="무궁화 고딕"/>
+                          <a:sym typeface="무궁화 고딕"/>
                         </a:rPr>
                         <a:t>서</a:t>
                       </a:r>
@@ -13741,10 +13737,10 @@
                           <a:solidFill>
                             <a:srgbClr val="000000"/>
                           </a:solidFill>
-                          <a:latin typeface="Jua"/>
-                          <a:ea typeface="Jua"/>
-                          <a:cs typeface="Jua"/>
-                          <a:sym typeface="Jua"/>
+                          <a:latin typeface="무궁화 고딕"/>
+                          <a:ea typeface="무궁화 고딕"/>
+                          <a:cs typeface="무궁화 고딕"/>
+                          <a:sym typeface="무궁화 고딕"/>
                         </a:rPr>
                         <a:t>바</a:t>
                       </a:r>
@@ -13808,10 +13804,10 @@
                           <a:solidFill>
                             <a:srgbClr val="000000"/>
                           </a:solidFill>
-                          <a:latin typeface="Jua"/>
-                          <a:ea typeface="Jua"/>
-                          <a:cs typeface="Jua"/>
-                          <a:sym typeface="Jua"/>
+                          <a:latin typeface="무궁화 고딕"/>
+                          <a:ea typeface="무궁화 고딕"/>
+                          <a:cs typeface="무궁화 고딕"/>
+                          <a:sym typeface="무궁화 고딕"/>
                         </a:rPr>
                         <a:t>일</a:t>
                       </a:r>
@@ -13873,10 +13869,10 @@
                           <a:solidFill>
                             <a:srgbClr val="000000"/>
                           </a:solidFill>
-                          <a:latin typeface="Jua"/>
-                          <a:ea typeface="Jua"/>
-                          <a:cs typeface="Jua"/>
-                          <a:sym typeface="Jua"/>
+                          <a:latin typeface="무궁화 고딕"/>
+                          <a:ea typeface="무궁화 고딕"/>
+                          <a:cs typeface="무궁화 고딕"/>
+                          <a:sym typeface="무궁화 고딕"/>
                         </a:rPr>
                         <a:t>리</a:t>
                       </a:r>
@@ -13938,10 +13934,10 @@
                           <a:solidFill>
                             <a:srgbClr val="000000"/>
                           </a:solidFill>
-                          <a:latin typeface="Jua"/>
-                          <a:ea typeface="Jua"/>
-                          <a:cs typeface="Jua"/>
-                          <a:sym typeface="Jua"/>
+                          <a:latin typeface="무궁화 고딕"/>
+                          <a:ea typeface="무궁화 고딕"/>
+                          <a:cs typeface="무궁화 고딕"/>
+                          <a:sym typeface="무궁화 고딕"/>
                         </a:rPr>
                         <a:t>어</a:t>
                       </a:r>
@@ -14003,10 +13999,10 @@
                           <a:solidFill>
                             <a:srgbClr val="000000"/>
                           </a:solidFill>
-                          <a:latin typeface="Jua"/>
-                          <a:ea typeface="Jua"/>
-                          <a:cs typeface="Jua"/>
-                          <a:sym typeface="Jua"/>
+                          <a:latin typeface="무궁화 고딕"/>
+                          <a:ea typeface="무궁화 고딕"/>
+                          <a:cs typeface="무궁화 고딕"/>
+                          <a:sym typeface="무궁화 고딕"/>
                         </a:rPr>
                         <a:t>제</a:t>
                       </a:r>
@@ -14147,8 +14143,8 @@
         </p:nvSpPr>
         <p:spPr>
           <a:xfrm rot="0">
-            <a:off x="461635" y="3895725"/>
-            <a:ext cx="17364730" cy="2200275"/>
+            <a:off x="461635" y="4238625"/>
+            <a:ext cx="17364730" cy="1800225"/>
           </a:xfrm>
           <a:prstGeom prst="rect">
             <a:avLst/>
@@ -14162,18 +14158,18 @@
           <a:p>
             <a:pPr algn="ctr">
               <a:lnSpc>
-                <a:spcPts val="15000"/>
+                <a:spcPts val="14160"/>
               </a:lnSpc>
             </a:pPr>
             <a:r>
-              <a:rPr lang="en-US" sz="12500">
+              <a:rPr lang="en-US" sz="11800">
                 <a:solidFill>
                   <a:srgbClr val="000000"/>
                 </a:solidFill>
-                <a:latin typeface="Jua"/>
-                <a:ea typeface="Jua"/>
-                <a:cs typeface="Jua"/>
-                <a:sym typeface="Jua"/>
+                <a:latin typeface="무궁화 고딕"/>
+                <a:ea typeface="무궁화 고딕"/>
+                <a:cs typeface="무궁화 고딕"/>
+                <a:sym typeface="무궁화 고딕"/>
               </a:rPr>
               <a:t>일어나서 제자리 세바퀴 돌기</a:t>
             </a:r>
@@ -14251,10 +14247,10 @@
                           <a:solidFill>
                             <a:srgbClr val="000000"/>
                           </a:solidFill>
-                          <a:latin typeface="Jua"/>
-                          <a:ea typeface="Jua"/>
-                          <a:cs typeface="Jua"/>
-                          <a:sym typeface="Jua"/>
+                          <a:latin typeface="무궁화 고딕"/>
+                          <a:ea typeface="무궁화 고딕"/>
+                          <a:cs typeface="무궁화 고딕"/>
+                          <a:sym typeface="무궁화 고딕"/>
                         </a:rPr>
                         <a:t>만</a:t>
                       </a:r>
@@ -14316,10 +14312,10 @@
                           <a:solidFill>
                             <a:srgbClr val="000000"/>
                           </a:solidFill>
-                          <a:latin typeface="Jua"/>
-                          <a:ea typeface="Jua"/>
-                          <a:cs typeface="Jua"/>
-                          <a:sym typeface="Jua"/>
+                          <a:latin typeface="무궁화 고딕"/>
+                          <a:ea typeface="무궁화 고딕"/>
+                          <a:cs typeface="무궁화 고딕"/>
+                          <a:sym typeface="무궁화 고딕"/>
                         </a:rPr>
                         <a:t>기</a:t>
                       </a:r>
@@ -14381,10 +14377,10 @@
                           <a:solidFill>
                             <a:srgbClr val="000000"/>
                           </a:solidFill>
-                          <a:latin typeface="Jua"/>
-                          <a:ea typeface="Jua"/>
-                          <a:cs typeface="Jua"/>
-                          <a:sym typeface="Jua"/>
+                          <a:latin typeface="무궁화 고딕"/>
+                          <a:ea typeface="무궁화 고딕"/>
+                          <a:cs typeface="무궁화 고딕"/>
+                          <a:sym typeface="무궁화 고딕"/>
                         </a:rPr>
                         <a:t>손</a:t>
                       </a:r>
@@ -14446,10 +14442,10 @@
                           <a:solidFill>
                             <a:srgbClr val="000000"/>
                           </a:solidFill>
-                          <a:latin typeface="Jua"/>
-                          <a:ea typeface="Jua"/>
-                          <a:cs typeface="Jua"/>
-                          <a:sym typeface="Jua"/>
+                          <a:latin typeface="무궁화 고딕"/>
+                          <a:ea typeface="무궁화 고딕"/>
+                          <a:cs typeface="무궁화 고딕"/>
+                          <a:sym typeface="무궁화 고딕"/>
                         </a:rPr>
                         <a:t>람</a:t>
                       </a:r>
@@ -14513,10 +14509,10 @@
                           <a:solidFill>
                             <a:srgbClr val="000000"/>
                           </a:solidFill>
-                          <a:latin typeface="Jua"/>
-                          <a:ea typeface="Jua"/>
-                          <a:cs typeface="Jua"/>
-                          <a:sym typeface="Jua"/>
+                          <a:latin typeface="무궁화 고딕"/>
+                          <a:ea typeface="무궁화 고딕"/>
+                          <a:cs typeface="무궁화 고딕"/>
+                          <a:sym typeface="무궁화 고딕"/>
                         </a:rPr>
                         <a:t>부</a:t>
                       </a:r>
@@ -14578,10 +14574,10 @@
                           <a:solidFill>
                             <a:srgbClr val="000000"/>
                           </a:solidFill>
-                          <a:latin typeface="Jua"/>
-                          <a:ea typeface="Jua"/>
-                          <a:cs typeface="Jua"/>
-                          <a:sym typeface="Jua"/>
+                          <a:latin typeface="무궁화 고딕"/>
+                          <a:ea typeface="무궁화 고딕"/>
+                          <a:cs typeface="무궁화 고딕"/>
+                          <a:sym typeface="무궁화 고딕"/>
                         </a:rPr>
                         <a:t>옆</a:t>
                       </a:r>
@@ -14643,10 +14639,10 @@
                           <a:solidFill>
                             <a:srgbClr val="000000"/>
                           </a:solidFill>
-                          <a:latin typeface="Jua"/>
-                          <a:ea typeface="Jua"/>
-                          <a:cs typeface="Jua"/>
-                          <a:sym typeface="Jua"/>
+                          <a:latin typeface="무궁화 고딕"/>
+                          <a:ea typeface="무궁화 고딕"/>
+                          <a:cs typeface="무궁화 고딕"/>
+                          <a:sym typeface="무궁화 고딕"/>
                         </a:rPr>
                         <a:t>고</a:t>
                       </a:r>
@@ -14708,10 +14704,10 @@
                           <a:solidFill>
                             <a:srgbClr val="000000"/>
                           </a:solidFill>
-                          <a:latin typeface="Jua"/>
-                          <a:ea typeface="Jua"/>
-                          <a:cs typeface="Jua"/>
-                          <a:sym typeface="Jua"/>
+                          <a:latin typeface="무궁화 고딕"/>
+                          <a:ea typeface="무궁화 고딕"/>
+                          <a:cs typeface="무궁화 고딕"/>
+                          <a:sym typeface="무궁화 고딕"/>
                         </a:rPr>
                         <a:t>세</a:t>
                       </a:r>
@@ -14775,10 +14771,10 @@
                           <a:solidFill>
                             <a:srgbClr val="000000"/>
                           </a:solidFill>
-                          <a:latin typeface="Jua"/>
-                          <a:ea typeface="Jua"/>
-                          <a:cs typeface="Jua"/>
-                          <a:sym typeface="Jua"/>
+                          <a:latin typeface="무궁화 고딕"/>
+                          <a:ea typeface="무궁화 고딕"/>
+                          <a:cs typeface="무궁화 고딕"/>
+                          <a:sym typeface="무궁화 고딕"/>
                         </a:rPr>
                         <a:t>과</a:t>
                       </a:r>
@@ -14840,10 +14836,10 @@
                           <a:solidFill>
                             <a:srgbClr val="000000"/>
                           </a:solidFill>
-                          <a:latin typeface="Jua"/>
-                          <a:ea typeface="Jua"/>
-                          <a:cs typeface="Jua"/>
-                          <a:sym typeface="Jua"/>
+                          <a:latin typeface="무궁화 고딕"/>
+                          <a:ea typeface="무궁화 고딕"/>
+                          <a:cs typeface="무궁화 고딕"/>
+                          <a:sym typeface="무궁화 고딕"/>
                         </a:rPr>
                         <a:t>르</a:t>
                       </a:r>
@@ -14905,10 +14901,10 @@
                           <a:solidFill>
                             <a:srgbClr val="000000"/>
                           </a:solidFill>
-                          <a:latin typeface="Jua"/>
-                          <a:ea typeface="Jua"/>
-                          <a:cs typeface="Jua"/>
-                          <a:sym typeface="Jua"/>
+                          <a:latin typeface="무궁화 고딕"/>
+                          <a:ea typeface="무궁화 고딕"/>
+                          <a:cs typeface="무궁화 고딕"/>
+                          <a:sym typeface="무궁화 고딕"/>
                         </a:rPr>
                         <a:t>잡</a:t>
                       </a:r>
@@ -14970,10 +14966,10 @@
                           <a:solidFill>
                             <a:srgbClr val="000000"/>
                           </a:solidFill>
-                          <a:latin typeface="Jua"/>
-                          <a:ea typeface="Jua"/>
-                          <a:cs typeface="Jua"/>
-                          <a:sym typeface="Jua"/>
+                          <a:latin typeface="무궁화 고딕"/>
+                          <a:ea typeface="무궁화 고딕"/>
+                          <a:cs typeface="무궁화 고딕"/>
+                          <a:sym typeface="무궁화 고딕"/>
                         </a:rPr>
                         <a:t>사</a:t>
                       </a:r>
@@ -15114,8 +15110,8 @@
         </p:nvSpPr>
         <p:spPr>
           <a:xfrm rot="0">
-            <a:off x="461635" y="3895725"/>
-            <a:ext cx="17364730" cy="2200275"/>
+            <a:off x="461635" y="4243387"/>
+            <a:ext cx="17364730" cy="1790700"/>
           </a:xfrm>
           <a:prstGeom prst="rect">
             <a:avLst/>
@@ -15129,18 +15125,18 @@
           <a:p>
             <a:pPr algn="ctr">
               <a:lnSpc>
-                <a:spcPts val="15000"/>
+                <a:spcPts val="14040"/>
               </a:lnSpc>
             </a:pPr>
             <a:r>
-              <a:rPr lang="en-US" sz="12500">
+              <a:rPr lang="en-US" sz="11700">
                 <a:solidFill>
                   <a:srgbClr val="000000"/>
                 </a:solidFill>
-                <a:latin typeface="Jua"/>
-                <a:ea typeface="Jua"/>
-                <a:cs typeface="Jua"/>
-                <a:sym typeface="Jua"/>
+                <a:latin typeface="무궁화 고딕"/>
+                <a:ea typeface="무궁화 고딕"/>
+                <a:cs typeface="무궁화 고딕"/>
+                <a:sym typeface="무궁화 고딕"/>
               </a:rPr>
               <a:t>옆사람과 손잡고 만세 부르기</a:t>
             </a:r>
@@ -15218,10 +15214,10 @@
                           <a:solidFill>
                             <a:srgbClr val="000000"/>
                           </a:solidFill>
-                          <a:latin typeface="Jua"/>
-                          <a:ea typeface="Jua"/>
-                          <a:cs typeface="Jua"/>
-                          <a:sym typeface="Jua"/>
+                          <a:latin typeface="무궁화 고딕"/>
+                          <a:ea typeface="무궁화 고딕"/>
+                          <a:cs typeface="무궁화 고딕"/>
+                          <a:sym typeface="무궁화 고딕"/>
                         </a:rPr>
                         <a:t>버</a:t>
                       </a:r>
@@ -15283,10 +15279,10 @@
                           <a:solidFill>
                             <a:srgbClr val="000000"/>
                           </a:solidFill>
-                          <a:latin typeface="Jua"/>
-                          <a:ea typeface="Jua"/>
-                          <a:cs typeface="Jua"/>
-                          <a:sym typeface="Jua"/>
+                          <a:latin typeface="무궁화 고딕"/>
+                          <a:ea typeface="무궁화 고딕"/>
+                          <a:cs typeface="무궁화 고딕"/>
+                          <a:sym typeface="무궁화 고딕"/>
                         </a:rPr>
                         <a:t>한</a:t>
                       </a:r>
@@ -15348,10 +15344,10 @@
                           <a:solidFill>
                             <a:srgbClr val="000000"/>
                           </a:solidFill>
-                          <a:latin typeface="Jua"/>
-                          <a:ea typeface="Jua"/>
-                          <a:cs typeface="Jua"/>
-                          <a:sym typeface="Jua"/>
+                          <a:latin typeface="무궁화 고딕"/>
+                          <a:ea typeface="무궁화 고딕"/>
+                          <a:cs typeface="무궁화 고딕"/>
+                          <a:sym typeface="무궁화 고딕"/>
                         </a:rPr>
                         <a:t>십</a:t>
                       </a:r>
@@ -15413,10 +15409,10 @@
                           <a:solidFill>
                             <a:srgbClr val="000000"/>
                           </a:solidFill>
-                          <a:latin typeface="Jua"/>
-                          <a:ea typeface="Jua"/>
-                          <a:cs typeface="Jua"/>
-                          <a:sym typeface="Jua"/>
+                          <a:latin typeface="무궁화 고딕"/>
+                          <a:ea typeface="무궁화 고딕"/>
+                          <a:cs typeface="무궁화 고딕"/>
+                          <a:sym typeface="무궁화 고딕"/>
                         </a:rPr>
                         <a:t>눈</a:t>
                       </a:r>
@@ -15480,10 +15476,10 @@
                           <a:solidFill>
                             <a:srgbClr val="000000"/>
                           </a:solidFill>
-                          <a:latin typeface="Jua"/>
-                          <a:ea typeface="Jua"/>
-                          <a:cs typeface="Jua"/>
-                          <a:sym typeface="Jua"/>
+                          <a:latin typeface="무궁화 고딕"/>
+                          <a:ea typeface="무궁화 고딕"/>
+                          <a:cs typeface="무궁화 고딕"/>
+                          <a:sym typeface="무궁화 고딕"/>
                         </a:rPr>
                         <a:t>기</a:t>
                       </a:r>
@@ -15545,10 +15541,10 @@
                           <a:solidFill>
                             <a:srgbClr val="000000"/>
                           </a:solidFill>
-                          <a:latin typeface="Jua"/>
-                          <a:ea typeface="Jua"/>
-                          <a:cs typeface="Jua"/>
-                          <a:sym typeface="Jua"/>
+                          <a:latin typeface="무궁화 고딕"/>
+                          <a:ea typeface="무궁화 고딕"/>
+                          <a:cs typeface="무궁화 고딕"/>
+                          <a:sym typeface="무궁화 고딕"/>
                         </a:rPr>
                         <a:t>로</a:t>
                       </a:r>
@@ -15610,10 +15606,10 @@
                           <a:solidFill>
                             <a:srgbClr val="000000"/>
                           </a:solidFill>
-                          <a:latin typeface="Jua"/>
-                          <a:ea typeface="Jua"/>
-                          <a:cs typeface="Jua"/>
-                          <a:sym typeface="Jua"/>
+                          <a:latin typeface="무궁화 고딕"/>
+                          <a:ea typeface="무궁화 고딕"/>
+                          <a:cs typeface="무궁화 고딕"/>
+                          <a:sym typeface="무궁화 고딕"/>
                         </a:rPr>
                         <a:t>감</a:t>
                       </a:r>
@@ -15675,10 +15671,10 @@
                           <a:solidFill>
                             <a:srgbClr val="000000"/>
                           </a:solidFill>
-                          <a:latin typeface="Jua"/>
-                          <a:ea typeface="Jua"/>
-                          <a:cs typeface="Jua"/>
-                          <a:sym typeface="Jua"/>
+                          <a:latin typeface="무궁화 고딕"/>
+                          <a:ea typeface="무궁화 고딕"/>
+                          <a:cs typeface="무궁화 고딕"/>
+                          <a:sym typeface="무궁화 고딕"/>
                         </a:rPr>
                         <a:t>간</a:t>
                       </a:r>
@@ -15742,10 +15738,10 @@
                           <a:solidFill>
                             <a:srgbClr val="000000"/>
                           </a:solidFill>
-                          <a:latin typeface="Jua"/>
-                          <a:ea typeface="Jua"/>
-                          <a:cs typeface="Jua"/>
-                          <a:sym typeface="Jua"/>
+                          <a:latin typeface="무궁화 고딕"/>
+                          <a:ea typeface="무궁화 고딕"/>
+                          <a:cs typeface="무궁화 고딕"/>
+                          <a:sym typeface="무궁화 고딕"/>
                         </a:rPr>
                         <a:t>초</a:t>
                       </a:r>
@@ -15807,10 +15803,10 @@
                           <a:solidFill>
                             <a:srgbClr val="000000"/>
                           </a:solidFill>
-                          <a:latin typeface="Jua"/>
-                          <a:ea typeface="Jua"/>
-                          <a:cs typeface="Jua"/>
-                          <a:sym typeface="Jua"/>
+                          <a:latin typeface="무궁화 고딕"/>
+                          <a:ea typeface="무궁화 고딕"/>
+                          <a:cs typeface="무궁화 고딕"/>
+                          <a:sym typeface="무궁화 고딕"/>
                         </a:rPr>
                         <a:t>티</a:t>
                       </a:r>
@@ -15872,10 +15868,10 @@
                           <a:solidFill>
                             <a:srgbClr val="000000"/>
                           </a:solidFill>
-                          <a:latin typeface="Jua"/>
-                          <a:ea typeface="Jua"/>
-                          <a:cs typeface="Jua"/>
-                          <a:sym typeface="Jua"/>
+                          <a:latin typeface="무궁화 고딕"/>
+                          <a:ea typeface="무궁화 고딕"/>
+                          <a:cs typeface="무궁화 고딕"/>
+                          <a:sym typeface="무궁화 고딕"/>
                         </a:rPr>
                         <a:t>발</a:t>
                       </a:r>
@@ -15937,10 +15933,10 @@
                           <a:solidFill>
                             <a:srgbClr val="000000"/>
                           </a:solidFill>
-                          <a:latin typeface="Jua"/>
-                          <a:ea typeface="Jua"/>
-                          <a:cs typeface="Jua"/>
-                          <a:sym typeface="Jua"/>
+                          <a:latin typeface="무궁화 고딕"/>
+                          <a:ea typeface="무궁화 고딕"/>
+                          <a:cs typeface="무궁화 고딕"/>
+                          <a:sym typeface="무궁화 고딕"/>
                         </a:rPr>
                         <a:t>고</a:t>
                       </a:r>
@@ -16081,8 +16077,8 @@
         </p:nvSpPr>
         <p:spPr>
           <a:xfrm rot="0">
-            <a:off x="1028700" y="3892867"/>
-            <a:ext cx="15555091" cy="2200275"/>
+            <a:off x="1028700" y="4178617"/>
+            <a:ext cx="15555091" cy="1914525"/>
           </a:xfrm>
           <a:prstGeom prst="rect">
             <a:avLst/>
@@ -16104,10 +16100,10 @@
                 <a:solidFill>
                   <a:srgbClr val="FFFAEF"/>
                 </a:solidFill>
-                <a:latin typeface="Jua"/>
-                <a:ea typeface="Jua"/>
-                <a:cs typeface="Jua"/>
-                <a:sym typeface="Jua"/>
+                <a:latin typeface="무궁화 고딕"/>
+                <a:ea typeface="무궁화 고딕"/>
+                <a:cs typeface="무궁화 고딕"/>
+                <a:sym typeface="무궁화 고딕"/>
               </a:rPr>
               <a:t>문장 만들기 행동지령</a:t>
             </a:r>
@@ -16122,8 +16118,8 @@
         </p:nvSpPr>
         <p:spPr>
           <a:xfrm rot="0">
-            <a:off x="15264803" y="9812655"/>
-            <a:ext cx="2637975" cy="474345"/>
+            <a:off x="14242119" y="9822180"/>
+            <a:ext cx="3660660" cy="464820"/>
           </a:xfrm>
           <a:prstGeom prst="rect">
             <a:avLst/>
@@ -16148,10 +16144,10 @@
                 <a:solidFill>
                   <a:srgbClr val="FFFFFF"/>
                 </a:solidFill>
-                <a:latin typeface="TDTD갬성명조"/>
-                <a:ea typeface="TDTD갬성명조"/>
-                <a:cs typeface="TDTD갬성명조"/>
-                <a:sym typeface="TDTD갬성명조"/>
+                <a:latin typeface="무궁화 고딕"/>
+                <a:ea typeface="무궁화 고딕"/>
+                <a:cs typeface="무궁화 고딕"/>
+                <a:sym typeface="무궁화 고딕"/>
               </a:rPr>
               <a:t>ⓒ 2026. Sunday Play</a:t>
             </a:r>
@@ -16248,8 +16244,8 @@
         </p:nvSpPr>
         <p:spPr>
           <a:xfrm rot="0">
-            <a:off x="461635" y="3895725"/>
-            <a:ext cx="17364730" cy="2200275"/>
+            <a:off x="461635" y="4252913"/>
+            <a:ext cx="17364730" cy="1771650"/>
           </a:xfrm>
           <a:prstGeom prst="rect">
             <a:avLst/>
@@ -16263,18 +16259,18 @@
           <a:p>
             <a:pPr algn="ctr">
               <a:lnSpc>
-                <a:spcPts val="15000"/>
+                <a:spcPts val="13920"/>
               </a:lnSpc>
             </a:pPr>
             <a:r>
-              <a:rPr lang="en-US" sz="12500">
+              <a:rPr lang="en-US" sz="11600">
                 <a:solidFill>
                   <a:srgbClr val="000000"/>
                 </a:solidFill>
-                <a:latin typeface="Jua"/>
-                <a:ea typeface="Jua"/>
-                <a:cs typeface="Jua"/>
-                <a:sym typeface="Jua"/>
+                <a:latin typeface="무궁화 고딕"/>
+                <a:ea typeface="무궁화 고딕"/>
+                <a:cs typeface="무궁화 고딕"/>
+                <a:sym typeface="무궁화 고딕"/>
               </a:rPr>
               <a:t>눈 감고 한발로 십초간 버티기</a:t>
             </a:r>
@@ -16352,10 +16348,10 @@
                           <a:solidFill>
                             <a:srgbClr val="000000"/>
                           </a:solidFill>
-                          <a:latin typeface="Jua"/>
-                          <a:ea typeface="Jua"/>
-                          <a:cs typeface="Jua"/>
-                          <a:sym typeface="Jua"/>
+                          <a:latin typeface="무궁화 고딕"/>
+                          <a:ea typeface="무궁화 고딕"/>
+                          <a:cs typeface="무궁화 고딕"/>
+                          <a:sym typeface="무궁화 고딕"/>
                         </a:rPr>
                         <a:t>과</a:t>
                       </a:r>
@@ -16417,10 +16413,10 @@
                           <a:solidFill>
                             <a:srgbClr val="000000"/>
                           </a:solidFill>
-                          <a:latin typeface="Jua"/>
-                          <a:ea typeface="Jua"/>
-                          <a:cs typeface="Jua"/>
-                          <a:sym typeface="Jua"/>
+                          <a:latin typeface="무궁화 고딕"/>
+                          <a:ea typeface="무궁화 고딕"/>
+                          <a:cs typeface="무궁화 고딕"/>
+                          <a:sym typeface="무궁화 고딕"/>
                         </a:rPr>
                         <a:t>점</a:t>
                       </a:r>
@@ -16482,10 +16478,10 @@
                           <a:solidFill>
                             <a:srgbClr val="000000"/>
                           </a:solidFill>
-                          <a:latin typeface="Jua"/>
-                          <a:ea typeface="Jua"/>
-                          <a:cs typeface="Jua"/>
-                          <a:sym typeface="Jua"/>
+                          <a:latin typeface="무궁화 고딕"/>
+                          <a:ea typeface="무궁화 고딕"/>
+                          <a:cs typeface="무궁화 고딕"/>
+                          <a:sym typeface="무궁화 고딕"/>
                         </a:rPr>
                         <a:t>사</a:t>
                       </a:r>
@@ -16547,10 +16543,10 @@
                           <a:solidFill>
                             <a:srgbClr val="000000"/>
                           </a:solidFill>
-                          <a:latin typeface="Jua"/>
-                          <a:ea typeface="Jua"/>
-                          <a:cs typeface="Jua"/>
-                          <a:sym typeface="Jua"/>
+                          <a:latin typeface="무궁화 고딕"/>
+                          <a:ea typeface="무궁화 고딕"/>
+                          <a:cs typeface="무궁화 고딕"/>
+                          <a:sym typeface="무궁화 고딕"/>
                         </a:rPr>
                         <a:t>기</a:t>
                       </a:r>
@@ -16614,10 +16610,10 @@
                           <a:solidFill>
                             <a:srgbClr val="000000"/>
                           </a:solidFill>
-                          <a:latin typeface="Jua"/>
-                          <a:ea typeface="Jua"/>
-                          <a:cs typeface="Jua"/>
-                          <a:sym typeface="Jua"/>
+                          <a:latin typeface="무궁화 고딕"/>
+                          <a:ea typeface="무궁화 고딕"/>
+                          <a:cs typeface="무궁화 고딕"/>
+                          <a:sym typeface="무궁화 고딕"/>
                         </a:rPr>
                         <a:t>잡</a:t>
                       </a:r>
@@ -16679,10 +16675,10 @@
                           <a:solidFill>
                             <a:srgbClr val="000000"/>
                           </a:solidFill>
-                          <a:latin typeface="Jua"/>
-                          <a:ea typeface="Jua"/>
-                          <a:cs typeface="Jua"/>
-                          <a:sym typeface="Jua"/>
+                          <a:latin typeface="무궁화 고딕"/>
+                          <a:ea typeface="무궁화 고딕"/>
+                          <a:cs typeface="무궁화 고딕"/>
+                          <a:sym typeface="무궁화 고딕"/>
                         </a:rPr>
                         <a:t>양</a:t>
                       </a:r>
@@ -16744,10 +16740,10 @@
                           <a:solidFill>
                             <a:srgbClr val="000000"/>
                           </a:solidFill>
-                          <a:latin typeface="Jua"/>
-                          <a:ea typeface="Jua"/>
-                          <a:cs typeface="Jua"/>
-                          <a:sym typeface="Jua"/>
+                          <a:latin typeface="무궁화 고딕"/>
+                          <a:ea typeface="무궁화 고딕"/>
+                          <a:cs typeface="무궁화 고딕"/>
+                          <a:sym typeface="무궁화 고딕"/>
                         </a:rPr>
                         <a:t>프</a:t>
                       </a:r>
@@ -16809,10 +16805,10 @@
                           <a:solidFill>
                             <a:srgbClr val="000000"/>
                           </a:solidFill>
-                          <a:latin typeface="Jua"/>
-                          <a:ea typeface="Jua"/>
-                          <a:cs typeface="Jua"/>
-                          <a:sym typeface="Jua"/>
+                          <a:latin typeface="무궁화 고딕"/>
+                          <a:ea typeface="무궁화 고딕"/>
+                          <a:cs typeface="무궁화 고딕"/>
+                          <a:sym typeface="무궁화 고딕"/>
                         </a:rPr>
                         <a:t>람</a:t>
                       </a:r>
@@ -16876,10 +16872,10 @@
                           <a:solidFill>
                             <a:srgbClr val="000000"/>
                           </a:solidFill>
-                          <a:latin typeface="Jua"/>
-                          <a:ea typeface="Jua"/>
-                          <a:cs typeface="Jua"/>
-                          <a:sym typeface="Jua"/>
+                          <a:latin typeface="무궁화 고딕"/>
+                          <a:ea typeface="무궁화 고딕"/>
+                          <a:cs typeface="무궁화 고딕"/>
+                          <a:sym typeface="무궁화 고딕"/>
                         </a:rPr>
                         <a:t>하</a:t>
                       </a:r>
@@ -16941,10 +16937,10 @@
                           <a:solidFill>
                             <a:srgbClr val="000000"/>
                           </a:solidFill>
-                          <a:latin typeface="Jua"/>
-                          <a:ea typeface="Jua"/>
-                          <a:cs typeface="Jua"/>
-                          <a:sym typeface="Jua"/>
+                          <a:latin typeface="무궁화 고딕"/>
+                          <a:ea typeface="무궁화 고딕"/>
+                          <a:cs typeface="무궁화 고딕"/>
+                          <a:sym typeface="무궁화 고딕"/>
                         </a:rPr>
                         <a:t>고</a:t>
                       </a:r>
@@ -17006,10 +17002,10 @@
                           <a:solidFill>
                             <a:srgbClr val="000000"/>
                           </a:solidFill>
-                          <a:latin typeface="Jua"/>
-                          <a:ea typeface="Jua"/>
-                          <a:cs typeface="Jua"/>
-                          <a:sym typeface="Jua"/>
+                          <a:latin typeface="무궁화 고딕"/>
+                          <a:ea typeface="무궁화 고딕"/>
+                          <a:cs typeface="무궁화 고딕"/>
+                          <a:sym typeface="무궁화 고딕"/>
                         </a:rPr>
                         <a:t>옆</a:t>
                       </a:r>
@@ -17071,10 +17067,10 @@
                           <a:solidFill>
                             <a:srgbClr val="000000"/>
                           </a:solidFill>
-                          <a:latin typeface="Jua"/>
-                          <a:ea typeface="Jua"/>
-                          <a:cs typeface="Jua"/>
-                          <a:sym typeface="Jua"/>
+                          <a:latin typeface="무궁화 고딕"/>
+                          <a:ea typeface="무궁화 고딕"/>
+                          <a:cs typeface="무궁화 고딕"/>
+                          <a:sym typeface="무궁화 고딕"/>
                         </a:rPr>
                         <a:t>손</a:t>
                       </a:r>
@@ -17215,8 +17211,8 @@
         </p:nvSpPr>
         <p:spPr>
           <a:xfrm rot="0">
-            <a:off x="461635" y="3895725"/>
-            <a:ext cx="17364730" cy="2200275"/>
+            <a:off x="461635" y="4267200"/>
+            <a:ext cx="17364730" cy="1743075"/>
           </a:xfrm>
           <a:prstGeom prst="rect">
             <a:avLst/>
@@ -17230,18 +17226,18 @@
           <a:p>
             <a:pPr algn="ctr">
               <a:lnSpc>
-                <a:spcPts val="15000"/>
+                <a:spcPts val="13680"/>
               </a:lnSpc>
             </a:pPr>
             <a:r>
-              <a:rPr lang="en-US" sz="12500">
+              <a:rPr lang="en-US" sz="11400">
                 <a:solidFill>
                   <a:srgbClr val="000000"/>
                 </a:solidFill>
-                <a:latin typeface="Jua"/>
-                <a:ea typeface="Jua"/>
-                <a:cs typeface="Jua"/>
-                <a:sym typeface="Jua"/>
+                <a:latin typeface="무궁화 고딕"/>
+                <a:ea typeface="무궁화 고딕"/>
+                <a:cs typeface="무궁화 고딕"/>
+                <a:sym typeface="무궁화 고딕"/>
               </a:rPr>
               <a:t>양옆 사람과 손잡고 점프하기</a:t>
             </a:r>
@@ -17319,10 +17315,10 @@
                           <a:solidFill>
                             <a:srgbClr val="000000"/>
                           </a:solidFill>
-                          <a:latin typeface="Jua"/>
-                          <a:ea typeface="Jua"/>
-                          <a:cs typeface="Jua"/>
-                          <a:sym typeface="Jua"/>
+                          <a:latin typeface="무궁화 고딕"/>
+                          <a:ea typeface="무궁화 고딕"/>
+                          <a:cs typeface="무궁화 고딕"/>
+                          <a:sym typeface="무궁화 고딕"/>
                         </a:rPr>
                         <a:t>사</a:t>
                       </a:r>
@@ -17384,10 +17380,10 @@
                           <a:solidFill>
                             <a:srgbClr val="000000"/>
                           </a:solidFill>
-                          <a:latin typeface="Jua"/>
-                          <a:ea typeface="Jua"/>
-                          <a:cs typeface="Jua"/>
-                          <a:sym typeface="Jua"/>
+                          <a:latin typeface="무궁화 고딕"/>
+                          <a:ea typeface="무궁화 고딕"/>
+                          <a:cs typeface="무궁화 고딕"/>
+                          <a:sym typeface="무궁화 고딕"/>
                         </a:rPr>
                         <a:t>주</a:t>
                       </a:r>
@@ -17449,10 +17445,10 @@
                           <a:solidFill>
                             <a:srgbClr val="000000"/>
                           </a:solidFill>
-                          <a:latin typeface="Jua"/>
-                          <a:ea typeface="Jua"/>
-                          <a:cs typeface="Jua"/>
-                          <a:sym typeface="Jua"/>
+                          <a:latin typeface="무궁화 고딕"/>
+                          <a:ea typeface="무궁화 고딕"/>
+                          <a:cs typeface="무궁화 고딕"/>
+                          <a:sym typeface="무궁화 고딕"/>
                         </a:rPr>
                         <a:t>는</a:t>
                       </a:r>
@@ -17514,10 +17510,10 @@
                           <a:solidFill>
                             <a:srgbClr val="000000"/>
                           </a:solidFill>
-                          <a:latin typeface="Jua"/>
-                          <a:ea typeface="Jua"/>
-                          <a:cs typeface="Jua"/>
-                          <a:sym typeface="Jua"/>
+                          <a:latin typeface="무궁화 고딕"/>
+                          <a:ea typeface="무궁화 고딕"/>
+                          <a:cs typeface="무궁화 고딕"/>
+                          <a:sym typeface="무궁화 고딕"/>
                         </a:rPr>
                         <a:t>어</a:t>
                       </a:r>
@@ -17581,10 +17577,10 @@
                           <a:solidFill>
                             <a:srgbClr val="000000"/>
                           </a:solidFill>
-                          <a:latin typeface="Jua"/>
-                          <a:ea typeface="Jua"/>
-                          <a:cs typeface="Jua"/>
-                          <a:sym typeface="Jua"/>
+                          <a:latin typeface="무궁화 고딕"/>
+                          <a:ea typeface="무궁화 고딕"/>
+                          <a:cs typeface="무궁화 고딕"/>
+                          <a:sym typeface="무궁화 고딕"/>
                         </a:rPr>
                         <a:t>기</a:t>
                       </a:r>
@@ -17646,10 +17642,10 @@
                           <a:solidFill>
                             <a:srgbClr val="000000"/>
                           </a:solidFill>
-                          <a:latin typeface="Jua"/>
-                          <a:ea typeface="Jua"/>
-                          <a:cs typeface="Jua"/>
-                          <a:sym typeface="Jua"/>
+                          <a:latin typeface="무궁화 고딕"/>
+                          <a:ea typeface="무궁화 고딕"/>
+                          <a:cs typeface="무궁화 고딕"/>
+                          <a:sym typeface="무궁화 고딕"/>
                         </a:rPr>
                         <a:t>뒤</a:t>
                       </a:r>
@@ -17711,10 +17707,10 @@
                           <a:solidFill>
                             <a:srgbClr val="000000"/>
                           </a:solidFill>
-                          <a:latin typeface="Jua"/>
-                          <a:ea typeface="Jua"/>
-                          <a:cs typeface="Jua"/>
-                          <a:sym typeface="Jua"/>
+                          <a:latin typeface="무궁화 고딕"/>
+                          <a:ea typeface="무궁화 고딕"/>
+                          <a:cs typeface="무궁화 고딕"/>
+                          <a:sym typeface="무궁화 고딕"/>
                         </a:rPr>
                         <a:t>깨</a:t>
                       </a:r>
@@ -17776,10 +17772,10 @@
                           <a:solidFill>
                             <a:srgbClr val="000000"/>
                           </a:solidFill>
-                          <a:latin typeface="Jua"/>
-                          <a:ea typeface="Jua"/>
-                          <a:cs typeface="Jua"/>
-                          <a:sym typeface="Jua"/>
+                          <a:latin typeface="무궁화 고딕"/>
+                          <a:ea typeface="무궁화 고딕"/>
+                          <a:cs typeface="무궁화 고딕"/>
+                          <a:sym typeface="무궁화 고딕"/>
                         </a:rPr>
                         <a:t>무</a:t>
                       </a:r>
@@ -17843,10 +17839,10 @@
                           <a:solidFill>
                             <a:srgbClr val="000000"/>
                           </a:solidFill>
-                          <a:latin typeface="Jua"/>
-                          <a:ea typeface="Jua"/>
-                          <a:cs typeface="Jua"/>
-                          <a:sym typeface="Jua"/>
+                          <a:latin typeface="무궁화 고딕"/>
+                          <a:ea typeface="무궁화 고딕"/>
+                          <a:cs typeface="무궁화 고딕"/>
+                          <a:sym typeface="무궁화 고딕"/>
                         </a:rPr>
                         <a:t>람</a:t>
                       </a:r>
@@ -17908,10 +17904,10 @@
                           <a:solidFill>
                             <a:srgbClr val="000000"/>
                           </a:solidFill>
-                          <a:latin typeface="Jua"/>
-                          <a:ea typeface="Jua"/>
-                          <a:cs typeface="Jua"/>
-                          <a:sym typeface="Jua"/>
+                          <a:latin typeface="무궁화 고딕"/>
+                          <a:ea typeface="무궁화 고딕"/>
+                          <a:cs typeface="무궁화 고딕"/>
+                          <a:sym typeface="무궁화 고딕"/>
                         </a:rPr>
                         <a:t>있</a:t>
                       </a:r>
@@ -17973,10 +17969,10 @@
                           <a:solidFill>
                             <a:srgbClr val="000000"/>
                           </a:solidFill>
-                          <a:latin typeface="Jua"/>
-                          <a:ea typeface="Jua"/>
-                          <a:cs typeface="Jua"/>
-                          <a:sym typeface="Jua"/>
+                          <a:latin typeface="무궁화 고딕"/>
+                          <a:ea typeface="무궁화 고딕"/>
+                          <a:cs typeface="무궁화 고딕"/>
+                          <a:sym typeface="무궁화 고딕"/>
                         </a:rPr>
                         <a:t>에</a:t>
                       </a:r>
@@ -18038,10 +18034,10 @@
                           <a:solidFill>
                             <a:srgbClr val="000000"/>
                           </a:solidFill>
-                          <a:latin typeface="Jua"/>
-                          <a:ea typeface="Jua"/>
-                          <a:cs typeface="Jua"/>
-                          <a:sym typeface="Jua"/>
+                          <a:latin typeface="무궁화 고딕"/>
+                          <a:ea typeface="무궁화 고딕"/>
+                          <a:cs typeface="무궁화 고딕"/>
+                          <a:sym typeface="무궁화 고딕"/>
                         </a:rPr>
                         <a:t>르</a:t>
                       </a:r>
@@ -18182,8 +18178,8 @@
         </p:nvSpPr>
         <p:spPr>
           <a:xfrm rot="0">
-            <a:off x="461635" y="3895725"/>
-            <a:ext cx="17364730" cy="2200275"/>
+            <a:off x="461635" y="4243387"/>
+            <a:ext cx="17364730" cy="1790700"/>
           </a:xfrm>
           <a:prstGeom prst="rect">
             <a:avLst/>
@@ -18197,18 +18193,18 @@
           <a:p>
             <a:pPr algn="ctr">
               <a:lnSpc>
-                <a:spcPts val="15000"/>
+                <a:spcPts val="14040"/>
               </a:lnSpc>
             </a:pPr>
             <a:r>
-              <a:rPr lang="en-US" sz="12500">
+              <a:rPr lang="en-US" sz="11700">
                 <a:solidFill>
                   <a:srgbClr val="000000"/>
                 </a:solidFill>
-                <a:latin typeface="Jua"/>
-                <a:ea typeface="Jua"/>
-                <a:cs typeface="Jua"/>
-                <a:sym typeface="Jua"/>
+                <a:latin typeface="무궁화 고딕"/>
+                <a:ea typeface="무궁화 고딕"/>
+                <a:cs typeface="무궁화 고딕"/>
+                <a:sym typeface="무궁화 고딕"/>
               </a:rPr>
               <a:t>뒤에 있는 사람 어깨 주무르기</a:t>
             </a:r>
@@ -18280,8 +18276,8 @@
         </p:nvSpPr>
         <p:spPr>
           <a:xfrm rot="0">
-            <a:off x="4421807" y="3895725"/>
-            <a:ext cx="9444385" cy="2200275"/>
+            <a:off x="4421807" y="4181475"/>
+            <a:ext cx="9444385" cy="1914525"/>
           </a:xfrm>
           <a:prstGeom prst="rect">
             <a:avLst/>
@@ -18303,10 +18299,10 @@
                 <a:solidFill>
                   <a:srgbClr val="000000"/>
                 </a:solidFill>
-                <a:latin typeface="Jua"/>
-                <a:ea typeface="Jua"/>
-                <a:cs typeface="Jua"/>
-                <a:sym typeface="Jua"/>
+                <a:latin typeface="무궁화 고딕"/>
+                <a:ea typeface="무궁화 고딕"/>
+                <a:cs typeface="무궁화 고딕"/>
+                <a:sym typeface="무궁화 고딕"/>
               </a:rPr>
               <a:t>감사합니다!</a:t>
             </a:r>
@@ -18432,10 +18428,10 @@
                           <a:solidFill>
                             <a:srgbClr val="000000"/>
                           </a:solidFill>
-                          <a:latin typeface="Jua"/>
-                          <a:ea typeface="Jua"/>
-                          <a:cs typeface="Jua"/>
-                          <a:sym typeface="Jua"/>
+                          <a:latin typeface="무궁화 고딕"/>
+                          <a:ea typeface="무궁화 고딕"/>
+                          <a:cs typeface="무궁화 고딕"/>
+                          <a:sym typeface="무궁화 고딕"/>
                         </a:rPr>
                         <a:t>만</a:t>
                       </a:r>
@@ -18497,10 +18493,10 @@
                           <a:solidFill>
                             <a:srgbClr val="000000"/>
                           </a:solidFill>
-                          <a:latin typeface="Jua"/>
-                          <a:ea typeface="Jua"/>
-                          <a:cs typeface="Jua"/>
-                          <a:sym typeface="Jua"/>
+                          <a:latin typeface="무궁화 고딕"/>
+                          <a:ea typeface="무궁화 고딕"/>
+                          <a:cs typeface="무궁화 고딕"/>
+                          <a:sym typeface="무궁화 고딕"/>
                         </a:rPr>
                         <a:t>하</a:t>
                       </a:r>
@@ -18564,10 +18560,10 @@
                           <a:solidFill>
                             <a:srgbClr val="000000"/>
                           </a:solidFill>
-                          <a:latin typeface="Jua"/>
-                          <a:ea typeface="Jua"/>
-                          <a:cs typeface="Jua"/>
-                          <a:sym typeface="Jua"/>
+                          <a:latin typeface="무궁화 고딕"/>
+                          <a:ea typeface="무궁화 고딕"/>
+                          <a:cs typeface="무궁화 고딕"/>
+                          <a:sym typeface="무궁화 고딕"/>
                         </a:rPr>
                         <a:t>기</a:t>
                       </a:r>
@@ -18629,10 +18625,10 @@
                           <a:solidFill>
                             <a:srgbClr val="000000"/>
                           </a:solidFill>
-                          <a:latin typeface="Jua"/>
-                          <a:ea typeface="Jua"/>
-                          <a:cs typeface="Jua"/>
-                          <a:sym typeface="Jua"/>
+                          <a:latin typeface="무궁화 고딕"/>
+                          <a:ea typeface="무궁화 고딕"/>
+                          <a:cs typeface="무궁화 고딕"/>
+                          <a:sym typeface="무궁화 고딕"/>
                         </a:rPr>
                         <a:t>세</a:t>
                       </a:r>
@@ -18773,8 +18769,8 @@
         </p:nvSpPr>
         <p:spPr>
           <a:xfrm rot="0">
-            <a:off x="2717556" y="3895725"/>
-            <a:ext cx="12852888" cy="2200275"/>
+            <a:off x="2717556" y="4181475"/>
+            <a:ext cx="12852888" cy="1914525"/>
           </a:xfrm>
           <a:prstGeom prst="rect">
             <a:avLst/>
@@ -18796,10 +18792,10 @@
                 <a:solidFill>
                   <a:srgbClr val="000000"/>
                 </a:solidFill>
-                <a:latin typeface="Jua"/>
-                <a:ea typeface="Jua"/>
-                <a:cs typeface="Jua"/>
-                <a:sym typeface="Jua"/>
+                <a:latin typeface="무궁화 고딕"/>
+                <a:ea typeface="무궁화 고딕"/>
+                <a:cs typeface="무궁화 고딕"/>
+                <a:sym typeface="무궁화 고딕"/>
               </a:rPr>
               <a:t>만세하기</a:t>
             </a:r>
@@ -18875,10 +18871,10 @@
                           <a:solidFill>
                             <a:srgbClr val="000000"/>
                           </a:solidFill>
-                          <a:latin typeface="Jua"/>
-                          <a:ea typeface="Jua"/>
-                          <a:cs typeface="Jua"/>
-                          <a:sym typeface="Jua"/>
+                          <a:latin typeface="무궁화 고딕"/>
+                          <a:ea typeface="무궁화 고딕"/>
+                          <a:cs typeface="무궁화 고딕"/>
+                          <a:sym typeface="무궁화 고딕"/>
                         </a:rPr>
                         <a:t>박</a:t>
                       </a:r>
@@ -18940,10 +18936,10 @@
                           <a:solidFill>
                             <a:srgbClr val="000000"/>
                           </a:solidFill>
-                          <a:latin typeface="Jua"/>
-                          <a:ea typeface="Jua"/>
-                          <a:cs typeface="Jua"/>
-                          <a:sym typeface="Jua"/>
+                          <a:latin typeface="무궁화 고딕"/>
+                          <a:ea typeface="무궁화 고딕"/>
+                          <a:cs typeface="무궁화 고딕"/>
+                          <a:sym typeface="무궁화 고딕"/>
                         </a:rPr>
                         <a:t>치</a:t>
                       </a:r>
@@ -19007,10 +19003,10 @@
                           <a:solidFill>
                             <a:srgbClr val="000000"/>
                           </a:solidFill>
-                          <a:latin typeface="Jua"/>
-                          <a:ea typeface="Jua"/>
-                          <a:cs typeface="Jua"/>
-                          <a:sym typeface="Jua"/>
+                          <a:latin typeface="무궁화 고딕"/>
+                          <a:ea typeface="무궁화 고딕"/>
+                          <a:cs typeface="무궁화 고딕"/>
+                          <a:sym typeface="무궁화 고딕"/>
                         </a:rPr>
                         <a:t>기</a:t>
                       </a:r>
@@ -19072,10 +19068,10 @@
                           <a:solidFill>
                             <a:srgbClr val="000000"/>
                           </a:solidFill>
-                          <a:latin typeface="Jua"/>
-                          <a:ea typeface="Jua"/>
-                          <a:cs typeface="Jua"/>
-                          <a:sym typeface="Jua"/>
+                          <a:latin typeface="무궁화 고딕"/>
+                          <a:ea typeface="무궁화 고딕"/>
+                          <a:cs typeface="무궁화 고딕"/>
+                          <a:sym typeface="무궁화 고딕"/>
                         </a:rPr>
                         <a:t>수</a:t>
                       </a:r>
@@ -19216,8 +19212,8 @@
         </p:nvSpPr>
         <p:spPr>
           <a:xfrm rot="0">
-            <a:off x="2717556" y="3895725"/>
-            <a:ext cx="12852888" cy="2200275"/>
+            <a:off x="2717556" y="4181475"/>
+            <a:ext cx="12852888" cy="1914525"/>
           </a:xfrm>
           <a:prstGeom prst="rect">
             <a:avLst/>
@@ -19239,10 +19235,10 @@
                 <a:solidFill>
                   <a:srgbClr val="000000"/>
                 </a:solidFill>
-                <a:latin typeface="Jua"/>
-                <a:ea typeface="Jua"/>
-                <a:cs typeface="Jua"/>
-                <a:sym typeface="Jua"/>
+                <a:latin typeface="무궁화 고딕"/>
+                <a:ea typeface="무궁화 고딕"/>
+                <a:cs typeface="무궁화 고딕"/>
+                <a:sym typeface="무궁화 고딕"/>
               </a:rPr>
               <a:t>박수치기</a:t>
             </a:r>
@@ -19319,10 +19315,10 @@
                           <a:solidFill>
                             <a:srgbClr val="000000"/>
                           </a:solidFill>
-                          <a:latin typeface="Jua"/>
-                          <a:ea typeface="Jua"/>
-                          <a:cs typeface="Jua"/>
-                          <a:sym typeface="Jua"/>
+                          <a:latin typeface="무궁화 고딕"/>
+                          <a:ea typeface="무궁화 고딕"/>
+                          <a:cs typeface="무궁화 고딕"/>
+                          <a:sym typeface="무궁화 고딕"/>
                         </a:rPr>
                         <a:t>원</a:t>
                       </a:r>
@@ -19384,10 +19380,10 @@
                           <a:solidFill>
                             <a:srgbClr val="000000"/>
                           </a:solidFill>
-                          <a:latin typeface="Jua"/>
-                          <a:ea typeface="Jua"/>
-                          <a:cs typeface="Jua"/>
-                          <a:sym typeface="Jua"/>
+                          <a:latin typeface="무궁화 고딕"/>
+                          <a:ea typeface="무궁화 고딕"/>
+                          <a:cs typeface="무궁화 고딕"/>
+                          <a:sym typeface="무궁화 고딕"/>
                         </a:rPr>
                         <a:t>로</a:t>
                       </a:r>
@@ -19449,10 +19445,10 @@
                           <a:solidFill>
                             <a:srgbClr val="000000"/>
                           </a:solidFill>
-                          <a:latin typeface="Jua"/>
-                          <a:ea typeface="Jua"/>
-                          <a:cs typeface="Jua"/>
-                          <a:sym typeface="Jua"/>
+                          <a:latin typeface="무궁화 고딕"/>
+                          <a:ea typeface="무궁화 고딕"/>
+                          <a:cs typeface="무궁화 고딕"/>
+                          <a:sym typeface="무궁화 고딕"/>
                         </a:rPr>
                         <a:t>모</a:t>
                       </a:r>
@@ -19516,10 +19512,10 @@
                           <a:solidFill>
                             <a:srgbClr val="000000"/>
                           </a:solidFill>
-                          <a:latin typeface="Jua"/>
-                          <a:ea typeface="Jua"/>
-                          <a:cs typeface="Jua"/>
-                          <a:sym typeface="Jua"/>
+                          <a:latin typeface="무궁화 고딕"/>
+                          <a:ea typeface="무궁화 고딕"/>
+                          <a:cs typeface="무궁화 고딕"/>
+                          <a:sym typeface="무궁화 고딕"/>
                         </a:rPr>
                         <a:t>기</a:t>
                       </a:r>
@@ -19581,10 +19577,10 @@
                           <a:solidFill>
                             <a:srgbClr val="000000"/>
                           </a:solidFill>
-                          <a:latin typeface="Jua"/>
-                          <a:ea typeface="Jua"/>
-                          <a:cs typeface="Jua"/>
-                          <a:sym typeface="Jua"/>
+                          <a:latin typeface="무궁화 고딕"/>
+                          <a:ea typeface="무궁화 고딕"/>
+                          <a:cs typeface="무궁화 고딕"/>
+                          <a:sym typeface="무궁화 고딕"/>
                         </a:rPr>
                         <a:t>으</a:t>
                       </a:r>
@@ -19646,10 +19642,10 @@
                           <a:solidFill>
                             <a:srgbClr val="000000"/>
                           </a:solidFill>
-                          <a:latin typeface="Jua"/>
-                          <a:ea typeface="Jua"/>
-                          <a:cs typeface="Jua"/>
-                          <a:sym typeface="Jua"/>
+                          <a:latin typeface="무궁화 고딕"/>
+                          <a:ea typeface="무궁화 고딕"/>
+                          <a:cs typeface="무궁화 고딕"/>
+                          <a:sym typeface="무궁화 고딕"/>
                         </a:rPr>
                         <a:t>이</a:t>
                       </a:r>

</xml_diff>